<commit_message>
Record Step 3 seed-zero controls and replicate C1
</commit_message>
<xml_diff>
--- a/research/codex/reports/BRSET_mBRSET_Research_Update.pptx
+++ b/research/codex/reports/BRSET_mBRSET_Research_Update.pptx
@@ -3250,7 +3250,7 @@
                 </a:solidFill>
                 <a:latin typeface="Times New Roman"/>
               </a:rPr>
-              <a:t>12 September 2026</a:t>
+              <a:t>13 September 2026</a:t>
             </a:r>
           </a:p>
         </p:txBody>
@@ -6278,8 +6278,8 @@
           <p:nvPr/>
         </p:nvGraphicFramePr>
         <p:xfrm>
-          <a:off x="1051560" y="1417320"/>
-          <a:ext cx="10058400" cy="2057400"/>
+          <a:off x="411480" y="1353312"/>
+          <a:ext cx="11384277" cy="2331720"/>
         </p:xfrm>
         <a:graphic>
           <a:graphicData uri="http://schemas.openxmlformats.org/drawingml/2006/table">
@@ -6288,17 +6288,30 @@
                 <a:tableStyleId>{5C22544A-7EE6-4342-B048-85BDC9FD1C3A}</a:tableStyleId>
               </a:tblPr>
               <a:tblGrid>
-                <a:gridCol w="3108960"/>
-                <a:gridCol w="3474720"/>
-                <a:gridCol w="3474720"/>
+                <a:gridCol w="1831953"/>
+                <a:gridCol w="1635672"/>
+                <a:gridCol w="1177684"/>
+                <a:gridCol w="1962806"/>
+                <a:gridCol w="1635672"/>
+                <a:gridCol w="1177684"/>
+                <a:gridCol w="1962806"/>
               </a:tblGrid>
-              <a:tr h="685800">
+              <a:tr h="466344">
                 <a:tc>
                   <a:txBody>
                     <a:bodyPr/>
                     <a:lstStyle/>
                     <a:p>
                       <a:pPr algn="l"/>
+                      <a:r>
+                        <a:rPr sz="1200" b="1" i="0">
+                          <a:solidFill>
+                            <a:srgbClr val="FFFFFF"/>
+                          </a:solidFill>
+                          <a:latin typeface="Times New Roman"/>
+                        </a:rPr>
+                        <a:t>Arm</a:t>
+                      </a:r>
                     </a:p>
                   </a:txBody>
                   <a:tcPr marL="54864" marR="54864" marT="27432" marB="27432" anchor="ctr">
@@ -6314,13 +6327,13 @@
                     <a:p>
                       <a:pPr algn="ctr"/>
                       <a:r>
-                        <a:rPr sz="1600" b="1" i="0">
+                        <a:rPr sz="1200" b="1" i="0">
                           <a:solidFill>
                             <a:srgbClr val="FFFFFF"/>
                           </a:solidFill>
                           <a:latin typeface="Times New Roman"/>
                         </a:rPr>
-                        <a:t>Natural label mix</a:t>
+                        <a:t>DR F1</a:t>
                       </a:r>
                     </a:p>
                   </a:txBody>
@@ -6337,13 +6350,13 @@
                     <a:p>
                       <a:pPr algn="ctr"/>
                       <a:r>
-                        <a:rPr sz="1600" b="1" i="0">
+                        <a:rPr sz="1200" b="1" i="0">
                           <a:solidFill>
                             <a:srgbClr val="FFFFFF"/>
                           </a:solidFill>
                           <a:latin typeface="Times New Roman"/>
                         </a:rPr>
-                        <a:t>Target-matched DR/ME mix</a:t>
+                        <a:t>Δ</a:t>
                       </a:r>
                     </a:p>
                   </a:txBody>
@@ -6353,8 +6366,100 @@
                     </a:solidFill>
                   </a:tcPr>
                 </a:tc>
+                <a:tc>
+                  <a:txBody>
+                    <a:bodyPr/>
+                    <a:lstStyle/>
+                    <a:p>
+                      <a:pPr algn="ctr"/>
+                      <a:r>
+                        <a:rPr sz="1200" b="1" i="0">
+                          <a:solidFill>
+                            <a:srgbClr val="FFFFFF"/>
+                          </a:solidFill>
+                          <a:latin typeface="Times New Roman"/>
+                        </a:rPr>
+                        <a:t>DR AUROC</a:t>
+                      </a:r>
+                    </a:p>
+                  </a:txBody>
+                  <a:tcPr marL="54864" marR="54864" marT="27432" marB="27432" anchor="ctr">
+                    <a:solidFill>
+                      <a:srgbClr val="1F4E79"/>
+                    </a:solidFill>
+                  </a:tcPr>
+                </a:tc>
+                <a:tc>
+                  <a:txBody>
+                    <a:bodyPr/>
+                    <a:lstStyle/>
+                    <a:p>
+                      <a:pPr algn="ctr"/>
+                      <a:r>
+                        <a:rPr sz="1200" b="1" i="0">
+                          <a:solidFill>
+                            <a:srgbClr val="FFFFFF"/>
+                          </a:solidFill>
+                          <a:latin typeface="Times New Roman"/>
+                        </a:rPr>
+                        <a:t>ME F1</a:t>
+                      </a:r>
+                    </a:p>
+                  </a:txBody>
+                  <a:tcPr marL="54864" marR="54864" marT="27432" marB="27432" anchor="ctr">
+                    <a:solidFill>
+                      <a:srgbClr val="1F4E79"/>
+                    </a:solidFill>
+                  </a:tcPr>
+                </a:tc>
+                <a:tc>
+                  <a:txBody>
+                    <a:bodyPr/>
+                    <a:lstStyle/>
+                    <a:p>
+                      <a:pPr algn="ctr"/>
+                      <a:r>
+                        <a:rPr sz="1200" b="1" i="0">
+                          <a:solidFill>
+                            <a:srgbClr val="FFFFFF"/>
+                          </a:solidFill>
+                          <a:latin typeface="Times New Roman"/>
+                        </a:rPr>
+                        <a:t>Δ</a:t>
+                      </a:r>
+                    </a:p>
+                  </a:txBody>
+                  <a:tcPr marL="54864" marR="54864" marT="27432" marB="27432" anchor="ctr">
+                    <a:solidFill>
+                      <a:srgbClr val="1F4E79"/>
+                    </a:solidFill>
+                  </a:tcPr>
+                </a:tc>
+                <a:tc>
+                  <a:txBody>
+                    <a:bodyPr/>
+                    <a:lstStyle/>
+                    <a:p>
+                      <a:pPr algn="ctr"/>
+                      <a:r>
+                        <a:rPr sz="1200" b="1" i="0">
+                          <a:solidFill>
+                            <a:srgbClr val="FFFFFF"/>
+                          </a:solidFill>
+                          <a:latin typeface="Times New Roman"/>
+                        </a:rPr>
+                        <a:t>ME AUROC</a:t>
+                      </a:r>
+                    </a:p>
+                  </a:txBody>
+                  <a:tcPr marL="54864" marR="54864" marT="27432" marB="27432" anchor="ctr">
+                    <a:solidFill>
+                      <a:srgbClr val="1F4E79"/>
+                    </a:solidFill>
+                  </a:tcPr>
+                </a:tc>
               </a:tr>
-              <a:tr h="685800">
+              <a:tr h="466344">
                 <a:tc>
                   <a:txBody>
                     <a:bodyPr/>
@@ -6362,13 +6467,13 @@
                     <a:p>
                       <a:pPr algn="l"/>
                       <a:r>
-                        <a:rPr sz="1600" b="0" i="0">
+                        <a:rPr sz="1200" b="0" i="0">
                           <a:solidFill>
                             <a:srgbClr val="1E1E1E"/>
                           </a:solidFill>
                           <a:latin typeface="Times New Roman"/>
                         </a:rPr>
-                        <a:t>Natural domain ratio</a:t>
+                        <a:t>B1 existing</a:t>
                       </a:r>
                     </a:p>
                   </a:txBody>
@@ -6385,13 +6490,13 @@
                     <a:p>
                       <a:pPr algn="ctr"/>
                       <a:r>
-                        <a:rPr sz="1600" b="0" i="0">
+                        <a:rPr sz="1200" b="0" i="0">
                           <a:solidFill>
                             <a:srgbClr val="1E1E1E"/>
                           </a:solidFill>
                           <a:latin typeface="Times New Roman"/>
                         </a:rPr>
-                        <a:t>B1 existing</a:t>
+                        <a:t>0.8703</a:t>
                       </a:r>
                     </a:p>
                   </a:txBody>
@@ -6408,12 +6513,292 @@
                     <a:p>
                       <a:pPr algn="ctr"/>
                       <a:r>
-                        <a:rPr sz="1600" b="0" i="0">
+                        <a:rPr sz="1200" b="0" i="0">
                           <a:solidFill>
                             <a:srgbClr val="1E1E1E"/>
                           </a:solidFill>
                           <a:latin typeface="Times New Roman"/>
                         </a:rPr>
+                        <a:t>—</a:t>
+                      </a:r>
+                    </a:p>
+                  </a:txBody>
+                  <a:tcPr marL="54864" marR="54864" marT="27432" marB="27432" anchor="ctr">
+                    <a:solidFill>
+                      <a:srgbClr val="FFFFFF"/>
+                    </a:solidFill>
+                  </a:tcPr>
+                </a:tc>
+                <a:tc>
+                  <a:txBody>
+                    <a:bodyPr/>
+                    <a:lstStyle/>
+                    <a:p>
+                      <a:pPr algn="ctr"/>
+                      <a:r>
+                        <a:rPr sz="1200" b="0" i="0">
+                          <a:solidFill>
+                            <a:srgbClr val="1E1E1E"/>
+                          </a:solidFill>
+                          <a:latin typeface="Times New Roman"/>
+                        </a:rPr>
+                        <a:t>0.9563</a:t>
+                      </a:r>
+                    </a:p>
+                  </a:txBody>
+                  <a:tcPr marL="54864" marR="54864" marT="27432" marB="27432" anchor="ctr">
+                    <a:solidFill>
+                      <a:srgbClr val="FFFFFF"/>
+                    </a:solidFill>
+                  </a:tcPr>
+                </a:tc>
+                <a:tc>
+                  <a:txBody>
+                    <a:bodyPr/>
+                    <a:lstStyle/>
+                    <a:p>
+                      <a:pPr algn="ctr"/>
+                      <a:r>
+                        <a:rPr sz="1200" b="0" i="0">
+                          <a:solidFill>
+                            <a:srgbClr val="1E1E1E"/>
+                          </a:solidFill>
+                          <a:latin typeface="Times New Roman"/>
+                        </a:rPr>
+                        <a:t>0.8489</a:t>
+                      </a:r>
+                    </a:p>
+                  </a:txBody>
+                  <a:tcPr marL="54864" marR="54864" marT="27432" marB="27432" anchor="ctr">
+                    <a:solidFill>
+                      <a:srgbClr val="FFFFFF"/>
+                    </a:solidFill>
+                  </a:tcPr>
+                </a:tc>
+                <a:tc>
+                  <a:txBody>
+                    <a:bodyPr/>
+                    <a:lstStyle/>
+                    <a:p>
+                      <a:pPr algn="ctr"/>
+                      <a:r>
+                        <a:rPr sz="1200" b="0" i="0">
+                          <a:solidFill>
+                            <a:srgbClr val="1E1E1E"/>
+                          </a:solidFill>
+                          <a:latin typeface="Times New Roman"/>
+                        </a:rPr>
+                        <a:t>—</a:t>
+                      </a:r>
+                    </a:p>
+                  </a:txBody>
+                  <a:tcPr marL="54864" marR="54864" marT="27432" marB="27432" anchor="ctr">
+                    <a:solidFill>
+                      <a:srgbClr val="FFFFFF"/>
+                    </a:solidFill>
+                  </a:tcPr>
+                </a:tc>
+                <a:tc>
+                  <a:txBody>
+                    <a:bodyPr/>
+                    <a:lstStyle/>
+                    <a:p>
+                      <a:pPr algn="ctr"/>
+                      <a:r>
+                        <a:rPr sz="1200" b="0" i="0">
+                          <a:solidFill>
+                            <a:srgbClr val="1E1E1E"/>
+                          </a:solidFill>
+                          <a:latin typeface="Times New Roman"/>
+                        </a:rPr>
+                        <a:t>0.9904</a:t>
+                      </a:r>
+                    </a:p>
+                  </a:txBody>
+                  <a:tcPr marL="54864" marR="54864" marT="27432" marB="27432" anchor="ctr">
+                    <a:solidFill>
+                      <a:srgbClr val="FFFFFF"/>
+                    </a:solidFill>
+                  </a:tcPr>
+                </a:tc>
+              </a:tr>
+              <a:tr h="466344">
+                <a:tc>
+                  <a:txBody>
+                    <a:bodyPr/>
+                    <a:lstStyle/>
+                    <a:p>
+                      <a:pPr algn="l"/>
+                      <a:r>
+                        <a:rPr sz="1200" b="0" i="0">
+                          <a:solidFill>
+                            <a:srgbClr val="1E1E1E"/>
+                          </a:solidFill>
+                          <a:latin typeface="Times New Roman"/>
+                        </a:rPr>
+                        <a:t>C1</a:t>
+                      </a:r>
+                    </a:p>
+                  </a:txBody>
+                  <a:tcPr marL="54864" marR="54864" marT="27432" marB="27432" anchor="ctr">
+                    <a:solidFill>
+                      <a:srgbClr val="EBF1F7"/>
+                    </a:solidFill>
+                  </a:tcPr>
+                </a:tc>
+                <a:tc>
+                  <a:txBody>
+                    <a:bodyPr/>
+                    <a:lstStyle/>
+                    <a:p>
+                      <a:pPr algn="ctr"/>
+                      <a:r>
+                        <a:rPr sz="1200" b="0" i="0">
+                          <a:solidFill>
+                            <a:srgbClr val="1E1E1E"/>
+                          </a:solidFill>
+                          <a:latin typeface="Times New Roman"/>
+                        </a:rPr>
+                        <a:t>0.8768</a:t>
+                      </a:r>
+                    </a:p>
+                  </a:txBody>
+                  <a:tcPr marL="54864" marR="54864" marT="27432" marB="27432" anchor="ctr">
+                    <a:solidFill>
+                      <a:srgbClr val="EBF1F7"/>
+                    </a:solidFill>
+                  </a:tcPr>
+                </a:tc>
+                <a:tc>
+                  <a:txBody>
+                    <a:bodyPr/>
+                    <a:lstStyle/>
+                    <a:p>
+                      <a:pPr algn="ctr"/>
+                      <a:r>
+                        <a:rPr sz="1200" b="0" i="0">
+                          <a:solidFill>
+                            <a:srgbClr val="1E1E1E"/>
+                          </a:solidFill>
+                          <a:latin typeface="Times New Roman"/>
+                        </a:rPr>
+                        <a:t>+0.0065</a:t>
+                      </a:r>
+                    </a:p>
+                  </a:txBody>
+                  <a:tcPr marL="54864" marR="54864" marT="27432" marB="27432" anchor="ctr">
+                    <a:solidFill>
+                      <a:srgbClr val="EBF1F7"/>
+                    </a:solidFill>
+                  </a:tcPr>
+                </a:tc>
+                <a:tc>
+                  <a:txBody>
+                    <a:bodyPr/>
+                    <a:lstStyle/>
+                    <a:p>
+                      <a:pPr algn="ctr"/>
+                      <a:r>
+                        <a:rPr sz="1200" b="0" i="0">
+                          <a:solidFill>
+                            <a:srgbClr val="1E1E1E"/>
+                          </a:solidFill>
+                          <a:latin typeface="Times New Roman"/>
+                        </a:rPr>
+                        <a:t>0.9490</a:t>
+                      </a:r>
+                    </a:p>
+                  </a:txBody>
+                  <a:tcPr marL="54864" marR="54864" marT="27432" marB="27432" anchor="ctr">
+                    <a:solidFill>
+                      <a:srgbClr val="EBF1F7"/>
+                    </a:solidFill>
+                  </a:tcPr>
+                </a:tc>
+                <a:tc>
+                  <a:txBody>
+                    <a:bodyPr/>
+                    <a:lstStyle/>
+                    <a:p>
+                      <a:pPr algn="ctr"/>
+                      <a:r>
+                        <a:rPr sz="1200" b="0" i="0">
+                          <a:solidFill>
+                            <a:srgbClr val="1E1E1E"/>
+                          </a:solidFill>
+                          <a:latin typeface="Times New Roman"/>
+                        </a:rPr>
+                        <a:t>0.8636</a:t>
+                      </a:r>
+                    </a:p>
+                  </a:txBody>
+                  <a:tcPr marL="54864" marR="54864" marT="27432" marB="27432" anchor="ctr">
+                    <a:solidFill>
+                      <a:srgbClr val="EBF1F7"/>
+                    </a:solidFill>
+                  </a:tcPr>
+                </a:tc>
+                <a:tc>
+                  <a:txBody>
+                    <a:bodyPr/>
+                    <a:lstStyle/>
+                    <a:p>
+                      <a:pPr algn="ctr"/>
+                      <a:r>
+                        <a:rPr sz="1200" b="0" i="0">
+                          <a:solidFill>
+                            <a:srgbClr val="1E1E1E"/>
+                          </a:solidFill>
+                          <a:latin typeface="Times New Roman"/>
+                        </a:rPr>
+                        <a:t>+0.0147</a:t>
+                      </a:r>
+                    </a:p>
+                  </a:txBody>
+                  <a:tcPr marL="54864" marR="54864" marT="27432" marB="27432" anchor="ctr">
+                    <a:solidFill>
+                      <a:srgbClr val="EBF1F7"/>
+                    </a:solidFill>
+                  </a:tcPr>
+                </a:tc>
+                <a:tc>
+                  <a:txBody>
+                    <a:bodyPr/>
+                    <a:lstStyle/>
+                    <a:p>
+                      <a:pPr algn="ctr"/>
+                      <a:r>
+                        <a:rPr sz="1200" b="0" i="0">
+                          <a:solidFill>
+                            <a:srgbClr val="1E1E1E"/>
+                          </a:solidFill>
+                          <a:latin typeface="Times New Roman"/>
+                        </a:rPr>
+                        <a:t>0.9895</a:t>
+                      </a:r>
+                    </a:p>
+                  </a:txBody>
+                  <a:tcPr marL="54864" marR="54864" marT="27432" marB="27432" anchor="ctr">
+                    <a:solidFill>
+                      <a:srgbClr val="EBF1F7"/>
+                    </a:solidFill>
+                  </a:tcPr>
+                </a:tc>
+              </a:tr>
+              <a:tr h="466344">
+                <a:tc>
+                  <a:txBody>
+                    <a:bodyPr/>
+                    <a:lstStyle/>
+                    <a:p>
+                      <a:pPr algn="l"/>
+                      <a:r>
+                        <a:rPr sz="1200" b="0" i="0">
+                          <a:solidFill>
+                            <a:srgbClr val="1E1E1E"/>
+                          </a:solidFill>
+                          <a:latin typeface="Times New Roman"/>
+                        </a:rPr>
                         <a:t>C2</a:t>
                       </a:r>
                     </a:p>
@@ -6424,8 +6809,146 @@
                     </a:solidFill>
                   </a:tcPr>
                 </a:tc>
+                <a:tc>
+                  <a:txBody>
+                    <a:bodyPr/>
+                    <a:lstStyle/>
+                    <a:p>
+                      <a:pPr algn="ctr"/>
+                      <a:r>
+                        <a:rPr sz="1200" b="0" i="0">
+                          <a:solidFill>
+                            <a:srgbClr val="1E1E1E"/>
+                          </a:solidFill>
+                          <a:latin typeface="Times New Roman"/>
+                        </a:rPr>
+                        <a:t>0.8772</a:t>
+                      </a:r>
+                    </a:p>
+                  </a:txBody>
+                  <a:tcPr marL="54864" marR="54864" marT="27432" marB="27432" anchor="ctr">
+                    <a:solidFill>
+                      <a:srgbClr val="FFFFFF"/>
+                    </a:solidFill>
+                  </a:tcPr>
+                </a:tc>
+                <a:tc>
+                  <a:txBody>
+                    <a:bodyPr/>
+                    <a:lstStyle/>
+                    <a:p>
+                      <a:pPr algn="ctr"/>
+                      <a:r>
+                        <a:rPr sz="1200" b="0" i="0">
+                          <a:solidFill>
+                            <a:srgbClr val="1E1E1E"/>
+                          </a:solidFill>
+                          <a:latin typeface="Times New Roman"/>
+                        </a:rPr>
+                        <a:t>+0.0069</a:t>
+                      </a:r>
+                    </a:p>
+                  </a:txBody>
+                  <a:tcPr marL="54864" marR="54864" marT="27432" marB="27432" anchor="ctr">
+                    <a:solidFill>
+                      <a:srgbClr val="FFFFFF"/>
+                    </a:solidFill>
+                  </a:tcPr>
+                </a:tc>
+                <a:tc>
+                  <a:txBody>
+                    <a:bodyPr/>
+                    <a:lstStyle/>
+                    <a:p>
+                      <a:pPr algn="ctr"/>
+                      <a:r>
+                        <a:rPr sz="1200" b="0" i="0">
+                          <a:solidFill>
+                            <a:srgbClr val="1E1E1E"/>
+                          </a:solidFill>
+                          <a:latin typeface="Times New Roman"/>
+                        </a:rPr>
+                        <a:t>0.9551</a:t>
+                      </a:r>
+                    </a:p>
+                  </a:txBody>
+                  <a:tcPr marL="54864" marR="54864" marT="27432" marB="27432" anchor="ctr">
+                    <a:solidFill>
+                      <a:srgbClr val="FFFFFF"/>
+                    </a:solidFill>
+                  </a:tcPr>
+                </a:tc>
+                <a:tc>
+                  <a:txBody>
+                    <a:bodyPr/>
+                    <a:lstStyle/>
+                    <a:p>
+                      <a:pPr algn="ctr"/>
+                      <a:r>
+                        <a:rPr sz="1200" b="0" i="0">
+                          <a:solidFill>
+                            <a:srgbClr val="1E1E1E"/>
+                          </a:solidFill>
+                          <a:latin typeface="Times New Roman"/>
+                        </a:rPr>
+                        <a:t>0.8504</a:t>
+                      </a:r>
+                    </a:p>
+                  </a:txBody>
+                  <a:tcPr marL="54864" marR="54864" marT="27432" marB="27432" anchor="ctr">
+                    <a:solidFill>
+                      <a:srgbClr val="FFFFFF"/>
+                    </a:solidFill>
+                  </a:tcPr>
+                </a:tc>
+                <a:tc>
+                  <a:txBody>
+                    <a:bodyPr/>
+                    <a:lstStyle/>
+                    <a:p>
+                      <a:pPr algn="ctr"/>
+                      <a:r>
+                        <a:rPr sz="1200" b="0" i="0">
+                          <a:solidFill>
+                            <a:srgbClr val="1E1E1E"/>
+                          </a:solidFill>
+                          <a:latin typeface="Times New Roman"/>
+                        </a:rPr>
+                        <a:t>+0.0015</a:t>
+                      </a:r>
+                    </a:p>
+                  </a:txBody>
+                  <a:tcPr marL="54864" marR="54864" marT="27432" marB="27432" anchor="ctr">
+                    <a:solidFill>
+                      <a:srgbClr val="FFFFFF"/>
+                    </a:solidFill>
+                  </a:tcPr>
+                </a:tc>
+                <a:tc>
+                  <a:txBody>
+                    <a:bodyPr/>
+                    <a:lstStyle/>
+                    <a:p>
+                      <a:pPr algn="ctr"/>
+                      <a:r>
+                        <a:rPr sz="1200" b="0" i="0">
+                          <a:solidFill>
+                            <a:srgbClr val="1E1E1E"/>
+                          </a:solidFill>
+                          <a:latin typeface="Times New Roman"/>
+                        </a:rPr>
+                        <a:t>0.9914</a:t>
+                      </a:r>
+                    </a:p>
+                  </a:txBody>
+                  <a:tcPr marL="54864" marR="54864" marT="27432" marB="27432" anchor="ctr">
+                    <a:solidFill>
+                      <a:srgbClr val="FFFFFF"/>
+                    </a:solidFill>
+                  </a:tcPr>
+                </a:tc>
               </a:tr>
-              <a:tr h="685800">
+              <a:tr h="466344">
                 <a:tc>
                   <a:txBody>
                     <a:bodyPr/>
@@ -6433,13 +6956,13 @@
                     <a:p>
                       <a:pPr algn="l"/>
                       <a:r>
-                        <a:rPr sz="1600" b="0" i="0">
+                        <a:rPr sz="1200" b="0" i="0">
                           <a:solidFill>
                             <a:srgbClr val="1E1E1E"/>
                           </a:solidFill>
                           <a:latin typeface="Times New Roman"/>
                         </a:rPr>
-                        <a:t>50% BRSET / 50% mBRSET</a:t>
+                        <a:t>C3</a:t>
                       </a:r>
                     </a:p>
                   </a:txBody>
@@ -6456,13 +6979,13 @@
                     <a:p>
                       <a:pPr algn="ctr"/>
                       <a:r>
-                        <a:rPr sz="1600" b="0" i="0">
+                        <a:rPr sz="1200" b="0" i="0">
                           <a:solidFill>
                             <a:srgbClr val="1E1E1E"/>
                           </a:solidFill>
                           <a:latin typeface="Times New Roman"/>
                         </a:rPr>
-                        <a:t>C1</a:t>
+                        <a:t>0.8739</a:t>
                       </a:r>
                     </a:p>
                   </a:txBody>
@@ -6479,13 +7002,105 @@
                     <a:p>
                       <a:pPr algn="ctr"/>
                       <a:r>
-                        <a:rPr sz="1600" b="0" i="0">
+                        <a:rPr sz="1200" b="0" i="0">
                           <a:solidFill>
                             <a:srgbClr val="1E1E1E"/>
                           </a:solidFill>
                           <a:latin typeface="Times New Roman"/>
                         </a:rPr>
-                        <a:t>C3</a:t>
+                        <a:t>+0.0036</a:t>
+                      </a:r>
+                    </a:p>
+                  </a:txBody>
+                  <a:tcPr marL="54864" marR="54864" marT="27432" marB="27432" anchor="ctr">
+                    <a:solidFill>
+                      <a:srgbClr val="EBF1F7"/>
+                    </a:solidFill>
+                  </a:tcPr>
+                </a:tc>
+                <a:tc>
+                  <a:txBody>
+                    <a:bodyPr/>
+                    <a:lstStyle/>
+                    <a:p>
+                      <a:pPr algn="ctr"/>
+                      <a:r>
+                        <a:rPr sz="1200" b="0" i="0">
+                          <a:solidFill>
+                            <a:srgbClr val="1E1E1E"/>
+                          </a:solidFill>
+                          <a:latin typeface="Times New Roman"/>
+                        </a:rPr>
+                        <a:t>0.9559</a:t>
+                      </a:r>
+                    </a:p>
+                  </a:txBody>
+                  <a:tcPr marL="54864" marR="54864" marT="27432" marB="27432" anchor="ctr">
+                    <a:solidFill>
+                      <a:srgbClr val="EBF1F7"/>
+                    </a:solidFill>
+                  </a:tcPr>
+                </a:tc>
+                <a:tc>
+                  <a:txBody>
+                    <a:bodyPr/>
+                    <a:lstStyle/>
+                    <a:p>
+                      <a:pPr algn="ctr"/>
+                      <a:r>
+                        <a:rPr sz="1200" b="0" i="0">
+                          <a:solidFill>
+                            <a:srgbClr val="1E1E1E"/>
+                          </a:solidFill>
+                          <a:latin typeface="Times New Roman"/>
+                        </a:rPr>
+                        <a:t>0.8507</a:t>
+                      </a:r>
+                    </a:p>
+                  </a:txBody>
+                  <a:tcPr marL="54864" marR="54864" marT="27432" marB="27432" anchor="ctr">
+                    <a:solidFill>
+                      <a:srgbClr val="EBF1F7"/>
+                    </a:solidFill>
+                  </a:tcPr>
+                </a:tc>
+                <a:tc>
+                  <a:txBody>
+                    <a:bodyPr/>
+                    <a:lstStyle/>
+                    <a:p>
+                      <a:pPr algn="ctr"/>
+                      <a:r>
+                        <a:rPr sz="1200" b="0" i="0">
+                          <a:solidFill>
+                            <a:srgbClr val="1E1E1E"/>
+                          </a:solidFill>
+                          <a:latin typeface="Times New Roman"/>
+                        </a:rPr>
+                        <a:t>+0.0018</a:t>
+                      </a:r>
+                    </a:p>
+                  </a:txBody>
+                  <a:tcPr marL="54864" marR="54864" marT="27432" marB="27432" anchor="ctr">
+                    <a:solidFill>
+                      <a:srgbClr val="EBF1F7"/>
+                    </a:solidFill>
+                  </a:tcPr>
+                </a:tc>
+                <a:tc>
+                  <a:txBody>
+                    <a:bodyPr/>
+                    <a:lstStyle/>
+                    <a:p>
+                      <a:pPr algn="ctr"/>
+                      <a:r>
+                        <a:rPr sz="1200" b="0" i="0">
+                          <a:solidFill>
+                            <a:srgbClr val="1E1E1E"/>
+                          </a:solidFill>
+                          <a:latin typeface="Times New Roman"/>
+                        </a:rPr>
+                        <a:t>0.9890</a:t>
                       </a:r>
                     </a:p>
                   </a:txBody>
@@ -6693,7 +7308,7 @@
                 </a:solidFill>
                 <a:latin typeface="Times New Roman"/>
               </a:rPr>
-              <a:t>Seed-0 controls submitted/running; no control result claimed yet.</a:t>
+              <a:t>Seed-0 controls verified; review the replication screen.</a:t>
             </a:r>
           </a:p>
         </p:txBody>

</xml_diff>

<commit_message>
Close Step 3 sampling controls
</commit_message>
<xml_diff>
--- a/research/codex/reports/BRSET_mBRSET_Research_Update.pptx
+++ b/research/codex/reports/BRSET_mBRSET_Research_Update.pptx
@@ -3160,7 +3160,7 @@
                 </a:solidFill>
                 <a:latin typeface="Times New Roman"/>
               </a:rPr>
-              <a:t>Evidence update: Step 2 complete; Step 3 controls prepared</a:t>
+              <a:t>Evidence update: Step 3 complete; appearance experiments next</a:t>
             </a:r>
           </a:p>
         </p:txBody>
@@ -3214,8 +3214,8 @@
                 </a:solidFill>
                 <a:latin typeface="Times New Roman"/>
               </a:rPr>
-              <a:t>Joint training improves DR and ME F1 in all three seeds.
-The mechanism and novelty are not yet established.</a:t>
+              <a:t>Natural joint training remains the strongest simple reference.
+A novel method has not yet been established.</a:t>
             </a:r>
           </a:p>
         </p:txBody>
@@ -7164,7 +7164,8 @@
                 </a:solidFill>
                 <a:latin typeface="Times New Roman"/>
               </a:rPr>
-              <a:t>Only the sampler changes</a:t>
+              <a:t>C1−B1 DR F1
++0.0035 mean</a:t>
             </a:r>
           </a:p>
         </p:txBody>
@@ -7218,7 +7219,8 @@
                 </a:solidFill>
                 <a:latin typeface="Times New Roman"/>
               </a:rPr>
-              <a:t>Validation-only screening</a:t>
+              <a:t>C1−B1 ME F1
++0.0079 mean</a:t>
             </a:r>
           </a:p>
         </p:txBody>
@@ -7272,8 +7274,8 @@
                 </a:solidFill>
                 <a:latin typeface="Times New Roman"/>
               </a:rPr>
-              <a:t>Allocated preflight
-PASSED</a:t>
+              <a:t>B1 retained
+Step 3 complete</a:t>
             </a:r>
           </a:p>
         </p:txBody>
@@ -7308,7 +7310,7 @@
                 </a:solidFill>
                 <a:latin typeface="Times New Roman"/>
               </a:rPr>
-              <a:t>Seed-0 controls verified; review the replication screen.</a:t>
+              <a:t>Step 3 complete; natural joint b1 retained for step 4.</a:t>
             </a:r>
           </a:p>
         </p:txBody>
@@ -7443,7 +7445,7 @@
                 </a:solidFill>
                 <a:latin typeface="Times New Roman"/>
               </a:rPr>
-              <a:t>First: select the simplest strong sampling baseline using cross-seed validation evidence.</a:t>
+              <a:t>Reference fixed: natural joint B1 after Step-3 cross-seed validation controls.</a:t>
             </a:r>
           </a:p>
           <a:p>
@@ -7459,7 +7461,7 @@
                 </a:solidFill>
                 <a:latin typeface="Times New Roman"/>
               </a:rPr>
-              <a:t>Then: test ordinary augmentation, a faithful published component, and FIT-only fitted degradation.</a:t>
+              <a:t>Next: test ordinary augmentation, a faithful published component, and FIT-only fitted degradation.</a:t>
             </a:r>
           </a:p>
           <a:p>

</xml_diff>

<commit_message>
Start audited Step 4 appearance study
</commit_message>
<xml_diff>
--- a/research/codex/reports/BRSET_mBRSET_Research_Update.pptx
+++ b/research/codex/reports/BRSET_mBRSET_Research_Update.pptx
@@ -3160,7 +3160,7 @@
                 </a:solidFill>
                 <a:latin typeface="Times New Roman"/>
               </a:rPr>
-              <a:t>Evidence update: Step 3 complete; appearance experiments next</a:t>
+              <a:t>Evidence update: Step 4 training-only appearance audit complete</a:t>
             </a:r>
           </a:p>
         </p:txBody>
@@ -3250,7 +3250,7 @@
                 </a:solidFill>
                 <a:latin typeface="Times New Roman"/>
               </a:rPr>
-              <a:t>13 September 2026</a:t>
+              <a:t>14 September 2026</a:t>
             </a:r>
           </a:p>
         </p:txBody>
@@ -7419,7 +7419,7 @@
         </p:nvSpPr>
         <p:spPr>
           <a:xfrm>
-            <a:off x="685800" y="1417320"/>
+            <a:off x="685800" y="1325880"/>
             <a:ext cx="10789920" cy="4754880"/>
           </a:xfrm>
           <a:prstGeom prst="rect">
@@ -7439,7 +7439,7 @@
               </a:spcAft>
             </a:pPr>
             <a:r>
-              <a:rPr sz="1900" b="0" i="0">
+              <a:rPr sz="1700" b="0" i="0">
                 <a:solidFill>
                   <a:srgbClr val="1E1E1E"/>
                 </a:solidFill>
@@ -7455,13 +7455,13 @@
               </a:spcAft>
             </a:pPr>
             <a:r>
-              <a:rPr sz="1900" b="0" i="0">
+              <a:rPr sz="1700" b="0" i="0">
                 <a:solidFill>
                   <a:srgbClr val="1E1E1E"/>
                 </a:solidFill>
                 <a:latin typeface="Times New Roman"/>
               </a:rPr>
-              <a:t>Next: test ordinary augmentation, a faithful published component, and FIT-only fitted degradation.</a:t>
+              <a:t>Training-only audit: label standardization changed every appearance gap by &lt;0.05 target SD.</a:t>
             </a:r>
           </a:p>
           <a:p>
@@ -7471,7 +7471,23 @@
               </a:spcAft>
             </a:pPr>
             <a:r>
-              <a:rPr sz="1900" b="0" i="0">
+              <a:rPr sz="1700" b="0" i="0">
+                <a:solidFill>
+                  <a:srgbClr val="1E1E1E"/>
+                </a:solidFill>
+                <a:latin typeface="Times New Roman"/>
+              </a:rPr>
+              <a:t>Next: test paper-faithful FundusAug, full fitted degradation, and an overlay-free fitted control.</a:t>
+            </a:r>
+          </a:p>
+          <a:p>
+            <a:pPr>
+              <a:spcAft>
+                <a:spcPts val="1200"/>
+              </a:spcAft>
+            </a:pPr>
+            <a:r>
+              <a:rPr sz="1700" b="0" i="0">
                 <a:solidFill>
                   <a:srgbClr val="1E1E1E"/>
                 </a:solidFill>
@@ -7487,7 +7503,7 @@
               </a:spcAft>
             </a:pPr>
             <a:r>
-              <a:rPr sz="1900" b="0" i="0">
+              <a:rPr sz="1700" b="0" i="0">
                 <a:solidFill>
                   <a:srgbClr val="1E1E1E"/>
                 </a:solidFill>

</xml_diff>

<commit_message>
Launch audited Step 4 augmentation screen
</commit_message>
<xml_diff>
--- a/research/codex/reports/BRSET_mBRSET_Research_Update.pptx
+++ b/research/codex/reports/BRSET_mBRSET_Research_Update.pptx
@@ -13,6 +13,7 @@
     <p:sldId id="261" r:id="rId12"/>
     <p:sldId id="262" r:id="rId13"/>
     <p:sldId id="263" r:id="rId14"/>
+    <p:sldId id="264" r:id="rId15"/>
   </p:sldIdLst>
   <p:sldSz cx="12191695" cy="6858000" type="screen4x3"/>
   <p:notesSz cx="6858000" cy="9144000"/>
@@ -3160,7 +3161,7 @@
                 </a:solidFill>
                 <a:latin typeface="Times New Roman"/>
               </a:rPr>
-              <a:t>Evidence update: Step 4 training-only appearance audit complete</a:t>
+              <a:t>Evidence update: Step 4 transform refit/preflight active</a:t>
             </a:r>
           </a:p>
         </p:txBody>
@@ -7419,8 +7420,8 @@
         </p:nvSpPr>
         <p:spPr>
           <a:xfrm>
-            <a:off x="685800" y="1325880"/>
-            <a:ext cx="10789920" cy="4754880"/>
+            <a:off x="685800" y="1234440"/>
+            <a:ext cx="10789920" cy="3611880"/>
           </a:xfrm>
           <a:prstGeom prst="rect">
             <a:avLst/>
@@ -7439,7 +7440,7 @@
               </a:spcAft>
             </a:pPr>
             <a:r>
-              <a:rPr sz="1700" b="0" i="0">
+              <a:rPr sz="1600" b="0" i="0">
                 <a:solidFill>
                   <a:srgbClr val="1E1E1E"/>
                 </a:solidFill>
@@ -7455,7 +7456,7 @@
               </a:spcAft>
             </a:pPr>
             <a:r>
-              <a:rPr sz="1700" b="0" i="0">
+              <a:rPr sz="1600" b="0" i="0">
                 <a:solidFill>
                   <a:srgbClr val="1E1E1E"/>
                 </a:solidFill>
@@ -7471,13 +7472,13 @@
               </a:spcAft>
             </a:pPr>
             <a:r>
-              <a:rPr sz="1700" b="0" i="0">
+              <a:rPr sz="1600" b="0" i="0">
                 <a:solidFill>
                   <a:srgbClr val="1E1E1E"/>
                 </a:solidFill>
                 <a:latin typeface="Times New Roman"/>
               </a:rPr>
-              <a:t>Next: test paper-faithful FundusAug, full fitted degradation, and an overlay-free fitted control.</a:t>
+              <a:t>Held-out appearance distance: unchanged 6.066; full fit 0.902; no overlays 0.942.</a:t>
             </a:r>
           </a:p>
           <a:p>
@@ -7487,13 +7488,13 @@
               </a:spcAft>
             </a:pPr>
             <a:r>
-              <a:rPr sz="1700" b="0" i="0">
+              <a:rPr sz="1600" b="0" i="0">
                 <a:solidFill>
                   <a:srgbClr val="1E1E1E"/>
                 </a:solidFill>
                 <a:latin typeface="Times New Roman"/>
               </a:rPr>
-              <a:t>Require: consistent diagnostic gain plus evidence that lesions are not damaged.</a:t>
+              <a:t>Next: test an independent release-range FundusAug artifact component, full fitted degradation, and an overlay-free fitted control.</a:t>
             </a:r>
           </a:p>
           <a:p>
@@ -7503,13 +7504,13 @@
               </a:spcAft>
             </a:pPr>
             <a:r>
-              <a:rPr sz="1700" b="0" i="0">
+              <a:rPr sz="1600" b="0" i="0">
                 <a:solidFill>
                   <a:srgbClr val="1E1E1E"/>
                 </a:solidFill>
                 <a:latin typeface="Times New Roman"/>
               </a:rPr>
-              <a:t>Claim novelty only after a closest-method comparison and an isolating ablation.</a:t>
+              <a:t>Require: consistent diagnostic gain, a closest-method comparison, an isolating ablation, and evidence that lesions are not damaged.</a:t>
             </a:r>
           </a:p>
         </p:txBody>
@@ -7564,6 +7565,512 @@
                 <a:latin typeface="Times New Roman"/>
               </a:rPr>
               <a:t>Current novelty status: candidate hypothesis, not demonstrated contribution</a:t>
+            </a:r>
+          </a:p>
+        </p:txBody>
+      </p:sp>
+    </p:spTree>
+  </p:cSld>
+  <p:clrMapOvr>
+    <a:masterClrMapping/>
+  </p:clrMapOvr>
+</p:sld>
+</file>
+
+<file path=ppt/slides/slide9.xml><?xml version="1.0" encoding="utf-8"?>
+<p:sld xmlns:a="http://schemas.openxmlformats.org/drawingml/2006/main" xmlns:p="http://schemas.openxmlformats.org/presentationml/2006/main" xmlns:r="http://schemas.openxmlformats.org/officeDocument/2006/relationships">
+  <p:cSld>
+    <p:spTree>
+      <p:nvGrpSpPr>
+        <p:cNvPr id="1" name=""/>
+        <p:cNvGrpSpPr/>
+        <p:nvPr/>
+      </p:nvGrpSpPr>
+      <p:grpSpPr/>
+      <p:sp>
+        <p:nvSpPr>
+          <p:cNvPr id="2" name="TextBox 1"/>
+          <p:cNvSpPr txBox="1"/>
+          <p:nvPr/>
+        </p:nvSpPr>
+        <p:spPr>
+          <a:xfrm>
+            <a:off x="502920" y="256032"/>
+            <a:ext cx="11155680" cy="457200"/>
+          </a:xfrm>
+          <a:prstGeom prst="rect">
+            <a:avLst/>
+          </a:prstGeom>
+          <a:noFill/>
+        </p:spPr>
+        <p:txBody>
+          <a:bodyPr wrap="square">
+            <a:spAutoFit/>
+          </a:bodyPr>
+          <a:lstStyle/>
+          <a:p>
+            <a:pPr algn="l"/>
+            <a:r>
+              <a:rPr sz="2700" b="1" i="0">
+                <a:solidFill>
+                  <a:srgbClr val="1F4E79"/>
+                </a:solidFill>
+                <a:latin typeface="Times New Roman"/>
+              </a:rPr>
+              <a:t>Dong requests and world-model decision</a:t>
+            </a:r>
+          </a:p>
+        </p:txBody>
+      </p:sp>
+      <p:sp>
+        <p:nvSpPr>
+          <p:cNvPr id="3" name="Rectangle 2"/>
+          <p:cNvSpPr/>
+          <p:nvPr/>
+        </p:nvSpPr>
+        <p:spPr>
+          <a:xfrm>
+            <a:off x="530352" y="1124712"/>
+            <a:ext cx="11064240" cy="18288"/>
+          </a:xfrm>
+          <a:prstGeom prst="rect">
+            <a:avLst/>
+          </a:prstGeom>
+          <a:solidFill>
+            <a:srgbClr val="1F4E79"/>
+          </a:solidFill>
+          <a:ln>
+            <a:noFill/>
+          </a:ln>
+        </p:spPr>
+        <p:style>
+          <a:lnRef idx="1">
+            <a:schemeClr val="accent1"/>
+          </a:lnRef>
+          <a:fillRef idx="3">
+            <a:schemeClr val="accent1"/>
+          </a:fillRef>
+          <a:effectRef idx="2">
+            <a:schemeClr val="accent1"/>
+          </a:effectRef>
+          <a:fontRef idx="minor">
+            <a:schemeClr val="lt1"/>
+          </a:fontRef>
+        </p:style>
+        <p:txBody>
+          <a:bodyPr rtlCol="0" anchor="ctr"/>
+          <a:lstStyle/>
+          <a:p>
+            <a:pPr algn="ctr"/>
+          </a:p>
+        </p:txBody>
+      </p:sp>
+      <p:sp>
+        <p:nvSpPr>
+          <p:cNvPr id="4" name="Rounded Rectangle 3"/>
+          <p:cNvSpPr/>
+          <p:nvPr/>
+        </p:nvSpPr>
+        <p:spPr>
+          <a:xfrm>
+            <a:off x="594360" y="1325880"/>
+            <a:ext cx="3474720" cy="548640"/>
+          </a:xfrm>
+          <a:prstGeom prst="roundRect">
+            <a:avLst/>
+          </a:prstGeom>
+          <a:solidFill>
+            <a:srgbClr val="E2EFE5"/>
+          </a:solidFill>
+          <a:ln>
+            <a:solidFill>
+              <a:srgbClr val="246943"/>
+            </a:solidFill>
+          </a:ln>
+        </p:spPr>
+        <p:style>
+          <a:lnRef idx="1">
+            <a:schemeClr val="accent1"/>
+          </a:lnRef>
+          <a:fillRef idx="3">
+            <a:schemeClr val="accent1"/>
+          </a:fillRef>
+          <a:effectRef idx="2">
+            <a:schemeClr val="accent1"/>
+          </a:effectRef>
+          <a:fontRef idx="minor">
+            <a:schemeClr val="lt1"/>
+          </a:fontRef>
+        </p:style>
+        <p:txBody>
+          <a:bodyPr rtlCol="0" anchor="ctr" wrap="square"/>
+          <a:lstStyle/>
+          <a:p>
+            <a:pPr algn="ctr"/>
+            <a:r>
+              <a:rPr sz="1900" b="1" i="0">
+                <a:solidFill>
+                  <a:srgbClr val="1E1E1E"/>
+                </a:solidFill>
+                <a:latin typeface="Times New Roman"/>
+              </a:rPr>
+              <a:t>Delivered</a:t>
+            </a:r>
+          </a:p>
+        </p:txBody>
+      </p:sp>
+      <p:sp>
+        <p:nvSpPr>
+          <p:cNvPr id="5" name="TextBox 4"/>
+          <p:cNvSpPr txBox="1"/>
+          <p:nvPr/>
+        </p:nvSpPr>
+        <p:spPr>
+          <a:xfrm>
+            <a:off x="685800" y="2057400"/>
+            <a:ext cx="3246120" cy="2834640"/>
+          </a:xfrm>
+          <a:prstGeom prst="rect">
+            <a:avLst/>
+          </a:prstGeom>
+          <a:noFill/>
+        </p:spPr>
+        <p:txBody>
+          <a:bodyPr wrap="square">
+            <a:spAutoFit/>
+          </a:bodyPr>
+          <a:lstStyle/>
+          <a:p>
+            <a:pPr>
+              <a:spcAft>
+                <a:spcPts val="1200"/>
+              </a:spcAft>
+            </a:pPr>
+            <a:r>
+              <a:rPr sz="1600" b="0" i="0">
+                <a:solidFill>
+                  <a:srgbClr val="1E1E1E"/>
+                </a:solidFill>
+                <a:latin typeface="Times New Roman"/>
+              </a:rPr>
+              <a:t>Matched baseline protocol</a:t>
+            </a:r>
+          </a:p>
+          <a:p>
+            <a:pPr>
+              <a:spcAft>
+                <a:spcPts val="1200"/>
+              </a:spcAft>
+            </a:pPr>
+            <a:r>
+              <a:rPr sz="1600" b="0" i="0">
+                <a:solidFill>
+                  <a:srgbClr val="1E1E1E"/>
+                </a:solidFill>
+                <a:latin typeface="Times New Roman"/>
+              </a:rPr>
+              <a:t>DR/ME prevalence and sampling controls</a:t>
+            </a:r>
+          </a:p>
+          <a:p>
+            <a:pPr>
+              <a:spcAft>
+                <a:spcPts val="1200"/>
+              </a:spcAft>
+            </a:pPr>
+            <a:r>
+              <a:rPr sz="1600" b="0" i="0">
+                <a:solidFill>
+                  <a:srgbClr val="1E1E1E"/>
+                </a:solidFill>
+                <a:latin typeface="Times New Roman"/>
+              </a:rPr>
+              <a:t>Source-verified degradation examples</a:t>
+            </a:r>
+          </a:p>
+        </p:txBody>
+      </p:sp>
+      <p:sp>
+        <p:nvSpPr>
+          <p:cNvPr id="6" name="Rounded Rectangle 5"/>
+          <p:cNvSpPr/>
+          <p:nvPr/>
+        </p:nvSpPr>
+        <p:spPr>
+          <a:xfrm>
+            <a:off x="4370832" y="1325880"/>
+            <a:ext cx="3474720" cy="548640"/>
+          </a:xfrm>
+          <a:prstGeom prst="roundRect">
+            <a:avLst/>
+          </a:prstGeom>
+          <a:solidFill>
+            <a:srgbClr val="FAF1DE"/>
+          </a:solidFill>
+          <a:ln>
+            <a:solidFill>
+              <a:srgbClr val="9A6710"/>
+            </a:solidFill>
+          </a:ln>
+        </p:spPr>
+        <p:style>
+          <a:lnRef idx="1">
+            <a:schemeClr val="accent1"/>
+          </a:lnRef>
+          <a:fillRef idx="3">
+            <a:schemeClr val="accent1"/>
+          </a:fillRef>
+          <a:effectRef idx="2">
+            <a:schemeClr val="accent1"/>
+          </a:effectRef>
+          <a:fontRef idx="minor">
+            <a:schemeClr val="lt1"/>
+          </a:fontRef>
+        </p:style>
+        <p:txBody>
+          <a:bodyPr rtlCol="0" anchor="ctr" wrap="square"/>
+          <a:lstStyle/>
+          <a:p>
+            <a:pPr algn="ctr"/>
+            <a:r>
+              <a:rPr sz="1900" b="1" i="0">
+                <a:solidFill>
+                  <a:srgbClr val="1E1E1E"/>
+                </a:solidFill>
+                <a:latin typeface="Times New Roman"/>
+              </a:rPr>
+              <a:t>Open</a:t>
+            </a:r>
+          </a:p>
+        </p:txBody>
+      </p:sp>
+      <p:sp>
+        <p:nvSpPr>
+          <p:cNvPr id="7" name="TextBox 6"/>
+          <p:cNvSpPr txBox="1"/>
+          <p:nvPr/>
+        </p:nvSpPr>
+        <p:spPr>
+          <a:xfrm>
+            <a:off x="4462272" y="2057400"/>
+            <a:ext cx="3246120" cy="2834640"/>
+          </a:xfrm>
+          <a:prstGeom prst="rect">
+            <a:avLst/>
+          </a:prstGeom>
+          <a:noFill/>
+        </p:spPr>
+        <p:txBody>
+          <a:bodyPr wrap="square">
+            <a:spAutoFit/>
+          </a:bodyPr>
+          <a:lstStyle/>
+          <a:p>
+            <a:pPr>
+              <a:spcAft>
+                <a:spcPts val="1200"/>
+              </a:spcAft>
+            </a:pPr>
+            <a:r>
+              <a:rPr sz="1600" b="0" i="0">
+                <a:solidFill>
+                  <a:srgbClr val="1E1E1E"/>
+                </a:solidFill>
+                <a:latin typeface="Times New Roman"/>
+              </a:rPr>
+              <a:t>Classifier benefit of fitted degradation</a:t>
+            </a:r>
+          </a:p>
+          <a:p>
+            <a:pPr>
+              <a:spcAft>
+                <a:spcPts val="1200"/>
+              </a:spcAft>
+            </a:pPr>
+            <a:r>
+              <a:rPr sz="1600" b="0" i="0">
+                <a:solidFill>
+                  <a:srgbClr val="1E1E1E"/>
+                </a:solidFill>
+                <a:latin typeface="Times New Roman"/>
+              </a:rPr>
+              <a:t>Diagnostic-preservation evidence</a:t>
+            </a:r>
+          </a:p>
+          <a:p>
+            <a:pPr>
+              <a:spcAft>
+                <a:spcPts val="1200"/>
+              </a:spcAft>
+            </a:pPr>
+            <a:r>
+              <a:rPr sz="1600" b="0" i="0">
+                <a:solidFill>
+                  <a:srgbClr val="1E1E1E"/>
+                </a:solidFill>
+                <a:latin typeface="Times New Roman"/>
+              </a:rPr>
+              <a:t>Fair longer-budget routing revisit</a:t>
+            </a:r>
+          </a:p>
+        </p:txBody>
+      </p:sp>
+      <p:sp>
+        <p:nvSpPr>
+          <p:cNvPr id="8" name="Rounded Rectangle 7"/>
+          <p:cNvSpPr/>
+          <p:nvPr/>
+        </p:nvSpPr>
+        <p:spPr>
+          <a:xfrm>
+            <a:off x="8147304" y="1325880"/>
+            <a:ext cx="3474720" cy="548640"/>
+          </a:xfrm>
+          <a:prstGeom prst="roundRect">
+            <a:avLst/>
+          </a:prstGeom>
+          <a:solidFill>
+            <a:srgbClr val="EBF1F7"/>
+          </a:solidFill>
+          <a:ln>
+            <a:solidFill>
+              <a:srgbClr val="1F4E79"/>
+            </a:solidFill>
+          </a:ln>
+        </p:spPr>
+        <p:style>
+          <a:lnRef idx="1">
+            <a:schemeClr val="accent1"/>
+          </a:lnRef>
+          <a:fillRef idx="3">
+            <a:schemeClr val="accent1"/>
+          </a:fillRef>
+          <a:effectRef idx="2">
+            <a:schemeClr val="accent1"/>
+          </a:effectRef>
+          <a:fontRef idx="minor">
+            <a:schemeClr val="lt1"/>
+          </a:fontRef>
+        </p:style>
+        <p:txBody>
+          <a:bodyPr rtlCol="0" anchor="ctr" wrap="square"/>
+          <a:lstStyle/>
+          <a:p>
+            <a:pPr algn="ctr"/>
+            <a:r>
+              <a:rPr sz="1900" b="1" i="0">
+                <a:solidFill>
+                  <a:srgbClr val="1E1E1E"/>
+                </a:solidFill>
+                <a:latin typeface="Times New Roman"/>
+              </a:rPr>
+              <a:t>World-model gate</a:t>
+            </a:r>
+          </a:p>
+        </p:txBody>
+      </p:sp>
+      <p:sp>
+        <p:nvSpPr>
+          <p:cNvPr id="9" name="TextBox 8"/>
+          <p:cNvSpPr txBox="1"/>
+          <p:nvPr/>
+        </p:nvSpPr>
+        <p:spPr>
+          <a:xfrm>
+            <a:off x="8238744" y="2057400"/>
+            <a:ext cx="3246120" cy="2834640"/>
+          </a:xfrm>
+          <a:prstGeom prst="rect">
+            <a:avLst/>
+          </a:prstGeom>
+          <a:noFill/>
+        </p:spPr>
+        <p:txBody>
+          <a:bodyPr wrap="square">
+            <a:spAutoFit/>
+          </a:bodyPr>
+          <a:lstStyle/>
+          <a:p>
+            <a:pPr>
+              <a:spcAft>
+                <a:spcPts val="1200"/>
+              </a:spcAft>
+            </a:pPr>
+            <a:r>
+              <a:rPr sz="1600" b="0" i="0">
+                <a:solidFill>
+                  <a:srgbClr val="1E1E1E"/>
+                </a:solidFill>
+                <a:latin typeface="Times New Roman"/>
+              </a:rPr>
+              <a:t>CheXWorld, CVPR 2025: closest conceptual match</a:t>
+            </a:r>
+          </a:p>
+          <a:p>
+            <a:pPr>
+              <a:spcAft>
+                <a:spcPts val="1200"/>
+              </a:spcAft>
+            </a:pPr>
+            <a:r>
+              <a:rPr sz="1600" b="0" i="0">
+                <a:solidFill>
+                  <a:srgbClr val="1E1E1E"/>
+                </a:solidFill>
+                <a:latin typeface="Times New Roman"/>
+              </a:rPr>
+              <a:t>GenDeg, CVPR 2025: separate diffusion option</a:t>
+            </a:r>
+          </a:p>
+          <a:p>
+            <a:pPr>
+              <a:spcAft>
+                <a:spcPts val="1200"/>
+              </a:spcAft>
+            </a:pPr>
+            <a:r>
+              <a:rPr sz="1600" b="0" i="0">
+                <a:solidFill>
+                  <a:srgbClr val="1E1E1E"/>
+                </a:solidFill>
+                <a:latin typeface="Times New Roman"/>
+              </a:rPr>
+              <a:t>Run only after Step 4 supports the premise</a:t>
+            </a:r>
+          </a:p>
+        </p:txBody>
+      </p:sp>
+      <p:sp>
+        <p:nvSpPr>
+          <p:cNvPr id="10" name="TextBox 9"/>
+          <p:cNvSpPr txBox="1"/>
+          <p:nvPr/>
+        </p:nvSpPr>
+        <p:spPr>
+          <a:xfrm>
+            <a:off x="777240" y="5623560"/>
+            <a:ext cx="10652760" cy="411480"/>
+          </a:xfrm>
+          <a:prstGeom prst="rect">
+            <a:avLst/>
+          </a:prstGeom>
+          <a:noFill/>
+        </p:spPr>
+        <p:txBody>
+          <a:bodyPr wrap="square">
+            <a:spAutoFit/>
+          </a:bodyPr>
+          <a:lstStyle/>
+          <a:p>
+            <a:pPr algn="ctr"/>
+            <a:r>
+              <a:rPr sz="1600" b="1" i="0">
+                <a:solidFill>
+                  <a:srgbClr val="1F4E79"/>
+                </a:solidFill>
+                <a:latin typeface="Times New Roman"/>
+              </a:rPr>
+              <a:t>Internal paper targets: complete draft 15 October • hard freeze 19 October • official deadline 26 October</a:t>
             </a:r>
           </a:p>
         </p:txBody>

</xml_diff>

<commit_message>
Record Step 4 seed zero augmentation results
</commit_message>
<xml_diff>
--- a/research/codex/reports/BRSET_mBRSET_Research_Update.pptx
+++ b/research/codex/reports/BRSET_mBRSET_Research_Update.pptx
@@ -3161,7 +3161,7 @@
                 </a:solidFill>
                 <a:latin typeface="Times New Roman"/>
               </a:rPr>
-              <a:t>Evidence update: Step 4 transform refit/preflight active</a:t>
+              <a:t>Evidence update: Step 4 seed-0 screen complete</a:t>
             </a:r>
           </a:p>
         </p:txBody>
@@ -3251,7 +3251,7 @@
                 </a:solidFill>
                 <a:latin typeface="Times New Roman"/>
               </a:rPr>
-              <a:t>14 September 2026</a:t>
+              <a:t>15 September 2026</a:t>
             </a:r>
           </a:p>
         </p:txBody>
@@ -7364,7 +7364,7 @@
                 </a:solidFill>
                 <a:latin typeface="Times New Roman"/>
               </a:rPr>
-              <a:t>Decision gate for the paper contribution</a:t>
+              <a:t>Step 4: target-calibrated augmentation screen</a:t>
             </a:r>
           </a:p>
         </p:txBody>
@@ -7412,16 +7412,978 @@
           </a:p>
         </p:txBody>
       </p:sp>
-      <p:sp>
-        <p:nvSpPr>
-          <p:cNvPr id="4" name="TextBox 3"/>
+      <p:graphicFrame>
+        <p:nvGraphicFramePr>
+          <p:cNvPr id="4" name="Table 3"/>
+          <p:cNvGraphicFramePr>
+            <a:graphicFrameLocks noGrp="1"/>
+          </p:cNvGraphicFramePr>
+          <p:nvPr/>
+        </p:nvGraphicFramePr>
+        <p:xfrm>
+          <a:off x="411480" y="1234440"/>
+          <a:ext cx="11384277" cy="2331720"/>
+        </p:xfrm>
+        <a:graphic>
+          <a:graphicData uri="http://schemas.openxmlformats.org/drawingml/2006/table">
+            <a:tbl>
+              <a:tblPr firstRow="1" bandRow="1">
+                <a:tableStyleId>{5C22544A-7EE6-4342-B048-85BDC9FD1C3A}</a:tableStyleId>
+              </a:tblPr>
+              <a:tblGrid>
+                <a:gridCol w="1328166"/>
+                <a:gridCol w="1581150"/>
+                <a:gridCol w="1075182"/>
+                <a:gridCol w="1644395"/>
+                <a:gridCol w="1581150"/>
+                <a:gridCol w="1075182"/>
+                <a:gridCol w="1644395"/>
+                <a:gridCol w="1454657"/>
+              </a:tblGrid>
+              <a:tr h="466344">
+                <a:tc>
+                  <a:txBody>
+                    <a:bodyPr/>
+                    <a:lstStyle/>
+                    <a:p>
+                      <a:pPr algn="l"/>
+                      <a:r>
+                        <a:rPr sz="1100" b="1" i="0">
+                          <a:solidFill>
+                            <a:srgbClr val="FFFFFF"/>
+                          </a:solidFill>
+                          <a:latin typeface="Times New Roman"/>
+                        </a:rPr>
+                        <a:t>Arm</a:t>
+                      </a:r>
+                    </a:p>
+                  </a:txBody>
+                  <a:tcPr marL="54864" marR="54864" marT="27432" marB="27432" anchor="ctr">
+                    <a:solidFill>
+                      <a:srgbClr val="1F4E79"/>
+                    </a:solidFill>
+                  </a:tcPr>
+                </a:tc>
+                <a:tc>
+                  <a:txBody>
+                    <a:bodyPr/>
+                    <a:lstStyle/>
+                    <a:p>
+                      <a:pPr algn="ctr"/>
+                      <a:r>
+                        <a:rPr sz="1100" b="1" i="0">
+                          <a:solidFill>
+                            <a:srgbClr val="FFFFFF"/>
+                          </a:solidFill>
+                          <a:latin typeface="Times New Roman"/>
+                        </a:rPr>
+                        <a:t>DR F1</a:t>
+                      </a:r>
+                    </a:p>
+                  </a:txBody>
+                  <a:tcPr marL="54864" marR="54864" marT="27432" marB="27432" anchor="ctr">
+                    <a:solidFill>
+                      <a:srgbClr val="1F4E79"/>
+                    </a:solidFill>
+                  </a:tcPr>
+                </a:tc>
+                <a:tc>
+                  <a:txBody>
+                    <a:bodyPr/>
+                    <a:lstStyle/>
+                    <a:p>
+                      <a:pPr algn="ctr"/>
+                      <a:r>
+                        <a:rPr sz="1100" b="1" i="0">
+                          <a:solidFill>
+                            <a:srgbClr val="FFFFFF"/>
+                          </a:solidFill>
+                          <a:latin typeface="Times New Roman"/>
+                        </a:rPr>
+                        <a:t>Δ</a:t>
+                      </a:r>
+                    </a:p>
+                  </a:txBody>
+                  <a:tcPr marL="54864" marR="54864" marT="27432" marB="27432" anchor="ctr">
+                    <a:solidFill>
+                      <a:srgbClr val="1F4E79"/>
+                    </a:solidFill>
+                  </a:tcPr>
+                </a:tc>
+                <a:tc>
+                  <a:txBody>
+                    <a:bodyPr/>
+                    <a:lstStyle/>
+                    <a:p>
+                      <a:pPr algn="ctr"/>
+                      <a:r>
+                        <a:rPr sz="1100" b="1" i="0">
+                          <a:solidFill>
+                            <a:srgbClr val="FFFFFF"/>
+                          </a:solidFill>
+                          <a:latin typeface="Times New Roman"/>
+                        </a:rPr>
+                        <a:t>DR AUC</a:t>
+                      </a:r>
+                    </a:p>
+                  </a:txBody>
+                  <a:tcPr marL="54864" marR="54864" marT="27432" marB="27432" anchor="ctr">
+                    <a:solidFill>
+                      <a:srgbClr val="1F4E79"/>
+                    </a:solidFill>
+                  </a:tcPr>
+                </a:tc>
+                <a:tc>
+                  <a:txBody>
+                    <a:bodyPr/>
+                    <a:lstStyle/>
+                    <a:p>
+                      <a:pPr algn="ctr"/>
+                      <a:r>
+                        <a:rPr sz="1100" b="1" i="0">
+                          <a:solidFill>
+                            <a:srgbClr val="FFFFFF"/>
+                          </a:solidFill>
+                          <a:latin typeface="Times New Roman"/>
+                        </a:rPr>
+                        <a:t>ME F1</a:t>
+                      </a:r>
+                    </a:p>
+                  </a:txBody>
+                  <a:tcPr marL="54864" marR="54864" marT="27432" marB="27432" anchor="ctr">
+                    <a:solidFill>
+                      <a:srgbClr val="1F4E79"/>
+                    </a:solidFill>
+                  </a:tcPr>
+                </a:tc>
+                <a:tc>
+                  <a:txBody>
+                    <a:bodyPr/>
+                    <a:lstStyle/>
+                    <a:p>
+                      <a:pPr algn="ctr"/>
+                      <a:r>
+                        <a:rPr sz="1100" b="1" i="0">
+                          <a:solidFill>
+                            <a:srgbClr val="FFFFFF"/>
+                          </a:solidFill>
+                          <a:latin typeface="Times New Roman"/>
+                        </a:rPr>
+                        <a:t>Δ</a:t>
+                      </a:r>
+                    </a:p>
+                  </a:txBody>
+                  <a:tcPr marL="54864" marR="54864" marT="27432" marB="27432" anchor="ctr">
+                    <a:solidFill>
+                      <a:srgbClr val="1F4E79"/>
+                    </a:solidFill>
+                  </a:tcPr>
+                </a:tc>
+                <a:tc>
+                  <a:txBody>
+                    <a:bodyPr/>
+                    <a:lstStyle/>
+                    <a:p>
+                      <a:pPr algn="ctr"/>
+                      <a:r>
+                        <a:rPr sz="1100" b="1" i="0">
+                          <a:solidFill>
+                            <a:srgbClr val="FFFFFF"/>
+                          </a:solidFill>
+                          <a:latin typeface="Times New Roman"/>
+                        </a:rPr>
+                        <a:t>ME AUC</a:t>
+                      </a:r>
+                    </a:p>
+                  </a:txBody>
+                  <a:tcPr marL="54864" marR="54864" marT="27432" marB="27432" anchor="ctr">
+                    <a:solidFill>
+                      <a:srgbClr val="1F4E79"/>
+                    </a:solidFill>
+                  </a:tcPr>
+                </a:tc>
+                <a:tc>
+                  <a:txBody>
+                    <a:bodyPr/>
+                    <a:lstStyle/>
+                    <a:p>
+                      <a:pPr algn="ctr"/>
+                      <a:r>
+                        <a:rPr sz="1100" b="1" i="0">
+                          <a:solidFill>
+                            <a:srgbClr val="FFFFFF"/>
+                          </a:solidFill>
+                          <a:latin typeface="Times New Roman"/>
+                        </a:rPr>
+                        <a:t>Gate</a:t>
+                      </a:r>
+                    </a:p>
+                  </a:txBody>
+                  <a:tcPr marL="54864" marR="54864" marT="27432" marB="27432" anchor="ctr">
+                    <a:solidFill>
+                      <a:srgbClr val="1F4E79"/>
+                    </a:solidFill>
+                  </a:tcPr>
+                </a:tc>
+              </a:tr>
+              <a:tr h="466344">
+                <a:tc>
+                  <a:txBody>
+                    <a:bodyPr/>
+                    <a:lstStyle/>
+                    <a:p>
+                      <a:pPr algn="l"/>
+                      <a:r>
+                        <a:rPr sz="1100" b="0" i="0">
+                          <a:solidFill>
+                            <a:srgbClr val="1E1E1E"/>
+                          </a:solidFill>
+                          <a:latin typeface="Times New Roman"/>
+                        </a:rPr>
+                        <a:t>B1</a:t>
+                      </a:r>
+                    </a:p>
+                  </a:txBody>
+                  <a:tcPr marL="54864" marR="54864" marT="27432" marB="27432" anchor="ctr">
+                    <a:solidFill>
+                      <a:srgbClr val="FFFFFF"/>
+                    </a:solidFill>
+                  </a:tcPr>
+                </a:tc>
+                <a:tc>
+                  <a:txBody>
+                    <a:bodyPr/>
+                    <a:lstStyle/>
+                    <a:p>
+                      <a:pPr algn="ctr"/>
+                      <a:r>
+                        <a:rPr sz="1100" b="0" i="0">
+                          <a:solidFill>
+                            <a:srgbClr val="1E1E1E"/>
+                          </a:solidFill>
+                          <a:latin typeface="Times New Roman"/>
+                        </a:rPr>
+                        <a:t>0.8703</a:t>
+                      </a:r>
+                    </a:p>
+                  </a:txBody>
+                  <a:tcPr marL="54864" marR="54864" marT="27432" marB="27432" anchor="ctr">
+                    <a:solidFill>
+                      <a:srgbClr val="FFFFFF"/>
+                    </a:solidFill>
+                  </a:tcPr>
+                </a:tc>
+                <a:tc>
+                  <a:txBody>
+                    <a:bodyPr/>
+                    <a:lstStyle/>
+                    <a:p>
+                      <a:pPr algn="ctr"/>
+                      <a:r>
+                        <a:rPr sz="1100" b="0" i="0">
+                          <a:solidFill>
+                            <a:srgbClr val="1E1E1E"/>
+                          </a:solidFill>
+                          <a:latin typeface="Times New Roman"/>
+                        </a:rPr>
+                        <a:t>—</a:t>
+                      </a:r>
+                    </a:p>
+                  </a:txBody>
+                  <a:tcPr marL="54864" marR="54864" marT="27432" marB="27432" anchor="ctr">
+                    <a:solidFill>
+                      <a:srgbClr val="FFFFFF"/>
+                    </a:solidFill>
+                  </a:tcPr>
+                </a:tc>
+                <a:tc>
+                  <a:txBody>
+                    <a:bodyPr/>
+                    <a:lstStyle/>
+                    <a:p>
+                      <a:pPr algn="ctr"/>
+                      <a:r>
+                        <a:rPr sz="1100" b="0" i="0">
+                          <a:solidFill>
+                            <a:srgbClr val="1E1E1E"/>
+                          </a:solidFill>
+                          <a:latin typeface="Times New Roman"/>
+                        </a:rPr>
+                        <a:t>0.9563</a:t>
+                      </a:r>
+                    </a:p>
+                  </a:txBody>
+                  <a:tcPr marL="54864" marR="54864" marT="27432" marB="27432" anchor="ctr">
+                    <a:solidFill>
+                      <a:srgbClr val="FFFFFF"/>
+                    </a:solidFill>
+                  </a:tcPr>
+                </a:tc>
+                <a:tc>
+                  <a:txBody>
+                    <a:bodyPr/>
+                    <a:lstStyle/>
+                    <a:p>
+                      <a:pPr algn="ctr"/>
+                      <a:r>
+                        <a:rPr sz="1100" b="0" i="0">
+                          <a:solidFill>
+                            <a:srgbClr val="1E1E1E"/>
+                          </a:solidFill>
+                          <a:latin typeface="Times New Roman"/>
+                        </a:rPr>
+                        <a:t>0.8489</a:t>
+                      </a:r>
+                    </a:p>
+                  </a:txBody>
+                  <a:tcPr marL="54864" marR="54864" marT="27432" marB="27432" anchor="ctr">
+                    <a:solidFill>
+                      <a:srgbClr val="FFFFFF"/>
+                    </a:solidFill>
+                  </a:tcPr>
+                </a:tc>
+                <a:tc>
+                  <a:txBody>
+                    <a:bodyPr/>
+                    <a:lstStyle/>
+                    <a:p>
+                      <a:pPr algn="ctr"/>
+                      <a:r>
+                        <a:rPr sz="1100" b="0" i="0">
+                          <a:solidFill>
+                            <a:srgbClr val="1E1E1E"/>
+                          </a:solidFill>
+                          <a:latin typeface="Times New Roman"/>
+                        </a:rPr>
+                        <a:t>—</a:t>
+                      </a:r>
+                    </a:p>
+                  </a:txBody>
+                  <a:tcPr marL="54864" marR="54864" marT="27432" marB="27432" anchor="ctr">
+                    <a:solidFill>
+                      <a:srgbClr val="FFFFFF"/>
+                    </a:solidFill>
+                  </a:tcPr>
+                </a:tc>
+                <a:tc>
+                  <a:txBody>
+                    <a:bodyPr/>
+                    <a:lstStyle/>
+                    <a:p>
+                      <a:pPr algn="ctr"/>
+                      <a:r>
+                        <a:rPr sz="1100" b="0" i="0">
+                          <a:solidFill>
+                            <a:srgbClr val="1E1E1E"/>
+                          </a:solidFill>
+                          <a:latin typeface="Times New Roman"/>
+                        </a:rPr>
+                        <a:t>0.9904</a:t>
+                      </a:r>
+                    </a:p>
+                  </a:txBody>
+                  <a:tcPr marL="54864" marR="54864" marT="27432" marB="27432" anchor="ctr">
+                    <a:solidFill>
+                      <a:srgbClr val="FFFFFF"/>
+                    </a:solidFill>
+                  </a:tcPr>
+                </a:tc>
+                <a:tc>
+                  <a:txBody>
+                    <a:bodyPr/>
+                    <a:lstStyle/>
+                    <a:p>
+                      <a:pPr algn="ctr"/>
+                      <a:r>
+                        <a:rPr sz="1100" b="0" i="0">
+                          <a:solidFill>
+                            <a:srgbClr val="1E1E1E"/>
+                          </a:solidFill>
+                          <a:latin typeface="Times New Roman"/>
+                        </a:rPr>
+                        <a:t>Ref</a:t>
+                      </a:r>
+                    </a:p>
+                  </a:txBody>
+                  <a:tcPr marL="54864" marR="54864" marT="27432" marB="27432" anchor="ctr">
+                    <a:solidFill>
+                      <a:srgbClr val="FFFFFF"/>
+                    </a:solidFill>
+                  </a:tcPr>
+                </a:tc>
+              </a:tr>
+              <a:tr h="466344">
+                <a:tc>
+                  <a:txBody>
+                    <a:bodyPr/>
+                    <a:lstStyle/>
+                    <a:p>
+                      <a:pPr algn="l"/>
+                      <a:r>
+                        <a:rPr sz="1100" b="0" i="0">
+                          <a:solidFill>
+                            <a:srgbClr val="1E1E1E"/>
+                          </a:solidFill>
+                          <a:latin typeface="Times New Roman"/>
+                        </a:rPr>
+                        <a:t>A1</a:t>
+                      </a:r>
+                    </a:p>
+                  </a:txBody>
+                  <a:tcPr marL="54864" marR="54864" marT="27432" marB="27432" anchor="ctr">
+                    <a:solidFill>
+                      <a:srgbClr val="EBF1F7"/>
+                    </a:solidFill>
+                  </a:tcPr>
+                </a:tc>
+                <a:tc>
+                  <a:txBody>
+                    <a:bodyPr/>
+                    <a:lstStyle/>
+                    <a:p>
+                      <a:pPr algn="ctr"/>
+                      <a:r>
+                        <a:rPr sz="1100" b="0" i="0">
+                          <a:solidFill>
+                            <a:srgbClr val="1E1E1E"/>
+                          </a:solidFill>
+                          <a:latin typeface="Times New Roman"/>
+                        </a:rPr>
+                        <a:t>0.8772</a:t>
+                      </a:r>
+                    </a:p>
+                  </a:txBody>
+                  <a:tcPr marL="54864" marR="54864" marT="27432" marB="27432" anchor="ctr">
+                    <a:solidFill>
+                      <a:srgbClr val="EBF1F7"/>
+                    </a:solidFill>
+                  </a:tcPr>
+                </a:tc>
+                <a:tc>
+                  <a:txBody>
+                    <a:bodyPr/>
+                    <a:lstStyle/>
+                    <a:p>
+                      <a:pPr algn="ctr"/>
+                      <a:r>
+                        <a:rPr sz="1100" b="0" i="0">
+                          <a:solidFill>
+                            <a:srgbClr val="1E1E1E"/>
+                          </a:solidFill>
+                          <a:latin typeface="Times New Roman"/>
+                        </a:rPr>
+                        <a:t>+0.0069</a:t>
+                      </a:r>
+                    </a:p>
+                  </a:txBody>
+                  <a:tcPr marL="54864" marR="54864" marT="27432" marB="27432" anchor="ctr">
+                    <a:solidFill>
+                      <a:srgbClr val="EBF1F7"/>
+                    </a:solidFill>
+                  </a:tcPr>
+                </a:tc>
+                <a:tc>
+                  <a:txBody>
+                    <a:bodyPr/>
+                    <a:lstStyle/>
+                    <a:p>
+                      <a:pPr algn="ctr"/>
+                      <a:r>
+                        <a:rPr sz="1100" b="0" i="0">
+                          <a:solidFill>
+                            <a:srgbClr val="1E1E1E"/>
+                          </a:solidFill>
+                          <a:latin typeface="Times New Roman"/>
+                        </a:rPr>
+                        <a:t>0.9530</a:t>
+                      </a:r>
+                    </a:p>
+                  </a:txBody>
+                  <a:tcPr marL="54864" marR="54864" marT="27432" marB="27432" anchor="ctr">
+                    <a:solidFill>
+                      <a:srgbClr val="EBF1F7"/>
+                    </a:solidFill>
+                  </a:tcPr>
+                </a:tc>
+                <a:tc>
+                  <a:txBody>
+                    <a:bodyPr/>
+                    <a:lstStyle/>
+                    <a:p>
+                      <a:pPr algn="ctr"/>
+                      <a:r>
+                        <a:rPr sz="1100" b="0" i="0">
+                          <a:solidFill>
+                            <a:srgbClr val="1E1E1E"/>
+                          </a:solidFill>
+                          <a:latin typeface="Times New Roman"/>
+                        </a:rPr>
+                        <a:t>0.8462</a:t>
+                      </a:r>
+                    </a:p>
+                  </a:txBody>
+                  <a:tcPr marL="54864" marR="54864" marT="27432" marB="27432" anchor="ctr">
+                    <a:solidFill>
+                      <a:srgbClr val="EBF1F7"/>
+                    </a:solidFill>
+                  </a:tcPr>
+                </a:tc>
+                <a:tc>
+                  <a:txBody>
+                    <a:bodyPr/>
+                    <a:lstStyle/>
+                    <a:p>
+                      <a:pPr algn="ctr"/>
+                      <a:r>
+                        <a:rPr sz="1100" b="0" i="0">
+                          <a:solidFill>
+                            <a:srgbClr val="1E1E1E"/>
+                          </a:solidFill>
+                          <a:latin typeface="Times New Roman"/>
+                        </a:rPr>
+                        <a:t>-0.0028</a:t>
+                      </a:r>
+                    </a:p>
+                  </a:txBody>
+                  <a:tcPr marL="54864" marR="54864" marT="27432" marB="27432" anchor="ctr">
+                    <a:solidFill>
+                      <a:srgbClr val="EBF1F7"/>
+                    </a:solidFill>
+                  </a:tcPr>
+                </a:tc>
+                <a:tc>
+                  <a:txBody>
+                    <a:bodyPr/>
+                    <a:lstStyle/>
+                    <a:p>
+                      <a:pPr algn="ctr"/>
+                      <a:r>
+                        <a:rPr sz="1100" b="0" i="0">
+                          <a:solidFill>
+                            <a:srgbClr val="1E1E1E"/>
+                          </a:solidFill>
+                          <a:latin typeface="Times New Roman"/>
+                        </a:rPr>
+                        <a:t>0.9904</a:t>
+                      </a:r>
+                    </a:p>
+                  </a:txBody>
+                  <a:tcPr marL="54864" marR="54864" marT="27432" marB="27432" anchor="ctr">
+                    <a:solidFill>
+                      <a:srgbClr val="EBF1F7"/>
+                    </a:solidFill>
+                  </a:tcPr>
+                </a:tc>
+                <a:tc>
+                  <a:txBody>
+                    <a:bodyPr/>
+                    <a:lstStyle/>
+                    <a:p>
+                      <a:pPr algn="ctr"/>
+                      <a:r>
+                        <a:rPr sz="1100" b="0" i="0">
+                          <a:solidFill>
+                            <a:srgbClr val="1E1E1E"/>
+                          </a:solidFill>
+                          <a:latin typeface="Times New Roman"/>
+                        </a:rPr>
+                        <a:t>FAIL</a:t>
+                      </a:r>
+                    </a:p>
+                  </a:txBody>
+                  <a:tcPr marL="54864" marR="54864" marT="27432" marB="27432" anchor="ctr">
+                    <a:solidFill>
+                      <a:srgbClr val="EBF1F7"/>
+                    </a:solidFill>
+                  </a:tcPr>
+                </a:tc>
+              </a:tr>
+              <a:tr h="466344">
+                <a:tc>
+                  <a:txBody>
+                    <a:bodyPr/>
+                    <a:lstStyle/>
+                    <a:p>
+                      <a:pPr algn="l"/>
+                      <a:r>
+                        <a:rPr sz="1100" b="0" i="0">
+                          <a:solidFill>
+                            <a:srgbClr val="1E1E1E"/>
+                          </a:solidFill>
+                          <a:latin typeface="Times New Roman"/>
+                        </a:rPr>
+                        <a:t>A2</a:t>
+                      </a:r>
+                    </a:p>
+                  </a:txBody>
+                  <a:tcPr marL="54864" marR="54864" marT="27432" marB="27432" anchor="ctr">
+                    <a:solidFill>
+                      <a:srgbClr val="FFFFFF"/>
+                    </a:solidFill>
+                  </a:tcPr>
+                </a:tc>
+                <a:tc>
+                  <a:txBody>
+                    <a:bodyPr/>
+                    <a:lstStyle/>
+                    <a:p>
+                      <a:pPr algn="ctr"/>
+                      <a:r>
+                        <a:rPr sz="1100" b="0" i="0">
+                          <a:solidFill>
+                            <a:srgbClr val="1E1E1E"/>
+                          </a:solidFill>
+                          <a:latin typeface="Times New Roman"/>
+                        </a:rPr>
+                        <a:t>0.8739</a:t>
+                      </a:r>
+                    </a:p>
+                  </a:txBody>
+                  <a:tcPr marL="54864" marR="54864" marT="27432" marB="27432" anchor="ctr">
+                    <a:solidFill>
+                      <a:srgbClr val="FFFFFF"/>
+                    </a:solidFill>
+                  </a:tcPr>
+                </a:tc>
+                <a:tc>
+                  <a:txBody>
+                    <a:bodyPr/>
+                    <a:lstStyle/>
+                    <a:p>
+                      <a:pPr algn="ctr"/>
+                      <a:r>
+                        <a:rPr sz="1100" b="0" i="0">
+                          <a:solidFill>
+                            <a:srgbClr val="1E1E1E"/>
+                          </a:solidFill>
+                          <a:latin typeface="Times New Roman"/>
+                        </a:rPr>
+                        <a:t>+0.0036</a:t>
+                      </a:r>
+                    </a:p>
+                  </a:txBody>
+                  <a:tcPr marL="54864" marR="54864" marT="27432" marB="27432" anchor="ctr">
+                    <a:solidFill>
+                      <a:srgbClr val="FFFFFF"/>
+                    </a:solidFill>
+                  </a:tcPr>
+                </a:tc>
+                <a:tc>
+                  <a:txBody>
+                    <a:bodyPr/>
+                    <a:lstStyle/>
+                    <a:p>
+                      <a:pPr algn="ctr"/>
+                      <a:r>
+                        <a:rPr sz="1100" b="0" i="0">
+                          <a:solidFill>
+                            <a:srgbClr val="1E1E1E"/>
+                          </a:solidFill>
+                          <a:latin typeface="Times New Roman"/>
+                        </a:rPr>
+                        <a:t>0.9558</a:t>
+                      </a:r>
+                    </a:p>
+                  </a:txBody>
+                  <a:tcPr marL="54864" marR="54864" marT="27432" marB="27432" anchor="ctr">
+                    <a:solidFill>
+                      <a:srgbClr val="FFFFFF"/>
+                    </a:solidFill>
+                  </a:tcPr>
+                </a:tc>
+                <a:tc>
+                  <a:txBody>
+                    <a:bodyPr/>
+                    <a:lstStyle/>
+                    <a:p>
+                      <a:pPr algn="ctr"/>
+                      <a:r>
+                        <a:rPr sz="1100" b="0" i="0">
+                          <a:solidFill>
+                            <a:srgbClr val="1E1E1E"/>
+                          </a:solidFill>
+                          <a:latin typeface="Times New Roman"/>
+                        </a:rPr>
+                        <a:t>0.8485</a:t>
+                      </a:r>
+                    </a:p>
+                  </a:txBody>
+                  <a:tcPr marL="54864" marR="54864" marT="27432" marB="27432" anchor="ctr">
+                    <a:solidFill>
+                      <a:srgbClr val="FFFFFF"/>
+                    </a:solidFill>
+                  </a:tcPr>
+                </a:tc>
+                <a:tc>
+                  <a:txBody>
+                    <a:bodyPr/>
+                    <a:lstStyle/>
+                    <a:p>
+                      <a:pPr algn="ctr"/>
+                      <a:r>
+                        <a:rPr sz="1100" b="0" i="0">
+                          <a:solidFill>
+                            <a:srgbClr val="1E1E1E"/>
+                          </a:solidFill>
+                          <a:latin typeface="Times New Roman"/>
+                        </a:rPr>
+                        <a:t>-0.0004</a:t>
+                      </a:r>
+                    </a:p>
+                  </a:txBody>
+                  <a:tcPr marL="54864" marR="54864" marT="27432" marB="27432" anchor="ctr">
+                    <a:solidFill>
+                      <a:srgbClr val="FFFFFF"/>
+                    </a:solidFill>
+                  </a:tcPr>
+                </a:tc>
+                <a:tc>
+                  <a:txBody>
+                    <a:bodyPr/>
+                    <a:lstStyle/>
+                    <a:p>
+                      <a:pPr algn="ctr"/>
+                      <a:r>
+                        <a:rPr sz="1100" b="0" i="0">
+                          <a:solidFill>
+                            <a:srgbClr val="1E1E1E"/>
+                          </a:solidFill>
+                          <a:latin typeface="Times New Roman"/>
+                        </a:rPr>
+                        <a:t>0.9906</a:t>
+                      </a:r>
+                    </a:p>
+                  </a:txBody>
+                  <a:tcPr marL="54864" marR="54864" marT="27432" marB="27432" anchor="ctr">
+                    <a:solidFill>
+                      <a:srgbClr val="FFFFFF"/>
+                    </a:solidFill>
+                  </a:tcPr>
+                </a:tc>
+                <a:tc>
+                  <a:txBody>
+                    <a:bodyPr/>
+                    <a:lstStyle/>
+                    <a:p>
+                      <a:pPr algn="ctr"/>
+                      <a:r>
+                        <a:rPr sz="1100" b="0" i="0">
+                          <a:solidFill>
+                            <a:srgbClr val="1E1E1E"/>
+                          </a:solidFill>
+                          <a:latin typeface="Times New Roman"/>
+                        </a:rPr>
+                        <a:t>FAIL</a:t>
+                      </a:r>
+                    </a:p>
+                  </a:txBody>
+                  <a:tcPr marL="54864" marR="54864" marT="27432" marB="27432" anchor="ctr">
+                    <a:solidFill>
+                      <a:srgbClr val="FFFFFF"/>
+                    </a:solidFill>
+                  </a:tcPr>
+                </a:tc>
+              </a:tr>
+              <a:tr h="466344">
+                <a:tc>
+                  <a:txBody>
+                    <a:bodyPr/>
+                    <a:lstStyle/>
+                    <a:p>
+                      <a:pPr algn="l"/>
+                      <a:r>
+                        <a:rPr sz="1100" b="0" i="0">
+                          <a:solidFill>
+                            <a:srgbClr val="1E1E1E"/>
+                          </a:solidFill>
+                          <a:latin typeface="Times New Roman"/>
+                        </a:rPr>
+                        <a:t>A3</a:t>
+                      </a:r>
+                    </a:p>
+                  </a:txBody>
+                  <a:tcPr marL="54864" marR="54864" marT="27432" marB="27432" anchor="ctr">
+                    <a:solidFill>
+                      <a:srgbClr val="EBF1F7"/>
+                    </a:solidFill>
+                  </a:tcPr>
+                </a:tc>
+                <a:tc>
+                  <a:txBody>
+                    <a:bodyPr/>
+                    <a:lstStyle/>
+                    <a:p>
+                      <a:pPr algn="ctr"/>
+                      <a:r>
+                        <a:rPr sz="1100" b="0" i="0">
+                          <a:solidFill>
+                            <a:srgbClr val="1E1E1E"/>
+                          </a:solidFill>
+                          <a:latin typeface="Times New Roman"/>
+                        </a:rPr>
+                        <a:t>0.8765</a:t>
+                      </a:r>
+                    </a:p>
+                  </a:txBody>
+                  <a:tcPr marL="54864" marR="54864" marT="27432" marB="27432" anchor="ctr">
+                    <a:solidFill>
+                      <a:srgbClr val="EBF1F7"/>
+                    </a:solidFill>
+                  </a:tcPr>
+                </a:tc>
+                <a:tc>
+                  <a:txBody>
+                    <a:bodyPr/>
+                    <a:lstStyle/>
+                    <a:p>
+                      <a:pPr algn="ctr"/>
+                      <a:r>
+                        <a:rPr sz="1100" b="0" i="0">
+                          <a:solidFill>
+                            <a:srgbClr val="1E1E1E"/>
+                          </a:solidFill>
+                          <a:latin typeface="Times New Roman"/>
+                        </a:rPr>
+                        <a:t>+0.0062</a:t>
+                      </a:r>
+                    </a:p>
+                  </a:txBody>
+                  <a:tcPr marL="54864" marR="54864" marT="27432" marB="27432" anchor="ctr">
+                    <a:solidFill>
+                      <a:srgbClr val="EBF1F7"/>
+                    </a:solidFill>
+                  </a:tcPr>
+                </a:tc>
+                <a:tc>
+                  <a:txBody>
+                    <a:bodyPr/>
+                    <a:lstStyle/>
+                    <a:p>
+                      <a:pPr algn="ctr"/>
+                      <a:r>
+                        <a:rPr sz="1100" b="0" i="0">
+                          <a:solidFill>
+                            <a:srgbClr val="1E1E1E"/>
+                          </a:solidFill>
+                          <a:latin typeface="Times New Roman"/>
+                        </a:rPr>
+                        <a:t>0.9601</a:t>
+                      </a:r>
+                    </a:p>
+                  </a:txBody>
+                  <a:tcPr marL="54864" marR="54864" marT="27432" marB="27432" anchor="ctr">
+                    <a:solidFill>
+                      <a:srgbClr val="EBF1F7"/>
+                    </a:solidFill>
+                  </a:tcPr>
+                </a:tc>
+                <a:tc>
+                  <a:txBody>
+                    <a:bodyPr/>
+                    <a:lstStyle/>
+                    <a:p>
+                      <a:pPr algn="ctr"/>
+                      <a:r>
+                        <a:rPr sz="1100" b="0" i="0">
+                          <a:solidFill>
+                            <a:srgbClr val="1E1E1E"/>
+                          </a:solidFill>
+                          <a:latin typeface="Times New Roman"/>
+                        </a:rPr>
+                        <a:t>0.8485</a:t>
+                      </a:r>
+                    </a:p>
+                  </a:txBody>
+                  <a:tcPr marL="54864" marR="54864" marT="27432" marB="27432" anchor="ctr">
+                    <a:solidFill>
+                      <a:srgbClr val="EBF1F7"/>
+                    </a:solidFill>
+                  </a:tcPr>
+                </a:tc>
+                <a:tc>
+                  <a:txBody>
+                    <a:bodyPr/>
+                    <a:lstStyle/>
+                    <a:p>
+                      <a:pPr algn="ctr"/>
+                      <a:r>
+                        <a:rPr sz="1100" b="0" i="0">
+                          <a:solidFill>
+                            <a:srgbClr val="1E1E1E"/>
+                          </a:solidFill>
+                          <a:latin typeface="Times New Roman"/>
+                        </a:rPr>
+                        <a:t>-0.0004</a:t>
+                      </a:r>
+                    </a:p>
+                  </a:txBody>
+                  <a:tcPr marL="54864" marR="54864" marT="27432" marB="27432" anchor="ctr">
+                    <a:solidFill>
+                      <a:srgbClr val="EBF1F7"/>
+                    </a:solidFill>
+                  </a:tcPr>
+                </a:tc>
+                <a:tc>
+                  <a:txBody>
+                    <a:bodyPr/>
+                    <a:lstStyle/>
+                    <a:p>
+                      <a:pPr algn="ctr"/>
+                      <a:r>
+                        <a:rPr sz="1100" b="0" i="0">
+                          <a:solidFill>
+                            <a:srgbClr val="1E1E1E"/>
+                          </a:solidFill>
+                          <a:latin typeface="Times New Roman"/>
+                        </a:rPr>
+                        <a:t>0.9903</a:t>
+                      </a:r>
+                    </a:p>
+                  </a:txBody>
+                  <a:tcPr marL="54864" marR="54864" marT="27432" marB="27432" anchor="ctr">
+                    <a:solidFill>
+                      <a:srgbClr val="EBF1F7"/>
+                    </a:solidFill>
+                  </a:tcPr>
+                </a:tc>
+                <a:tc>
+                  <a:txBody>
+                    <a:bodyPr/>
+                    <a:lstStyle/>
+                    <a:p>
+                      <a:pPr algn="ctr"/>
+                      <a:r>
+                        <a:rPr sz="1100" b="0" i="0">
+                          <a:solidFill>
+                            <a:srgbClr val="1E1E1E"/>
+                          </a:solidFill>
+                          <a:latin typeface="Times New Roman"/>
+                        </a:rPr>
+                        <a:t>FAIL</a:t>
+                      </a:r>
+                    </a:p>
+                  </a:txBody>
+                  <a:tcPr marL="54864" marR="54864" marT="27432" marB="27432" anchor="ctr">
+                    <a:solidFill>
+                      <a:srgbClr val="EBF1F7"/>
+                    </a:solidFill>
+                  </a:tcPr>
+                </a:tc>
+              </a:tr>
+            </a:tbl>
+          </a:graphicData>
+        </a:graphic>
+      </p:graphicFrame>
+      <p:sp>
+        <p:nvSpPr>
+          <p:cNvPr id="5" name="TextBox 4"/>
           <p:cNvSpPr txBox="1"/>
           <p:nvPr/>
         </p:nvSpPr>
         <p:spPr>
           <a:xfrm>
-            <a:off x="685800" y="1234440"/>
-            <a:ext cx="10789920" cy="3611880"/>
+            <a:off x="685800" y="3794760"/>
+            <a:ext cx="10789920" cy="1325880"/>
           </a:xfrm>
           <a:prstGeom prst="rect">
             <a:avLst/>
@@ -7440,23 +8402,7 @@
               </a:spcAft>
             </a:pPr>
             <a:r>
-              <a:rPr sz="1600" b="0" i="0">
-                <a:solidFill>
-                  <a:srgbClr val="1E1E1E"/>
-                </a:solidFill>
-                <a:latin typeface="Times New Roman"/>
-              </a:rPr>
-              <a:t>Reference fixed: natural joint B1 after Step-3 cross-seed validation controls.</a:t>
-            </a:r>
-          </a:p>
-          <a:p>
-            <a:pPr>
-              <a:spcAft>
-                <a:spcPts val="1200"/>
-              </a:spcAft>
-            </a:pPr>
-            <a:r>
-              <a:rPr sz="1600" b="0" i="0">
+              <a:rPr sz="1400" b="0" i="0">
                 <a:solidFill>
                   <a:srgbClr val="1E1E1E"/>
                 </a:solidFill>
@@ -7472,7 +8418,7 @@
               </a:spcAft>
             </a:pPr>
             <a:r>
-              <a:rPr sz="1600" b="0" i="0">
+              <a:rPr sz="1400" b="0" i="0">
                 <a:solidFill>
                   <a:srgbClr val="1E1E1E"/>
                 </a:solidFill>
@@ -7488,13 +8434,13 @@
               </a:spcAft>
             </a:pPr>
             <a:r>
-              <a:rPr sz="1600" b="0" i="0">
+              <a:rPr sz="1400" b="0" i="0">
                 <a:solidFill>
                   <a:srgbClr val="1E1E1E"/>
                 </a:solidFill>
                 <a:latin typeface="Times New Roman"/>
               </a:rPr>
-              <a:t>Next: test an independent release-range FundusAug artifact component, full fitted degradation, and an overlay-free fitted control.</a:t>
+              <a:t>All three DR F1 changes were positive but below +0.01; ME was flat or slightly lower.</a:t>
             </a:r>
           </a:p>
           <a:p>
@@ -7504,27 +8450,27 @@
               </a:spcAft>
             </a:pPr>
             <a:r>
-              <a:rPr sz="1600" b="0" i="0">
+              <a:rPr sz="1400" b="0" i="0">
                 <a:solidFill>
                   <a:srgbClr val="1E1E1E"/>
                 </a:solidFill>
                 <a:latin typeface="Times New Roman"/>
               </a:rPr>
-              <a:t>Require: consistent diagnostic gain, a closest-method comparison, an isolating ablation, and evidence that lesions are not damaged.</a:t>
-            </a:r>
-          </a:p>
-        </p:txBody>
-      </p:sp>
-      <p:sp>
-        <p:nvSpPr>
-          <p:cNvPr id="5" name="Rounded Rectangle 4"/>
+              <a:t>No arm passed the frozen replication gate; no Step-4 test assessment was performed.</a:t>
+            </a:r>
+          </a:p>
+        </p:txBody>
+      </p:sp>
+      <p:sp>
+        <p:nvSpPr>
+          <p:cNvPr id="6" name="Rounded Rectangle 5"/>
           <p:cNvSpPr/>
           <p:nvPr/>
         </p:nvSpPr>
         <p:spPr>
           <a:xfrm>
-            <a:off x="1097280" y="5166360"/>
-            <a:ext cx="9966960" cy="731520"/>
+            <a:off x="1097280" y="5349240"/>
+            <a:ext cx="9966960" cy="658368"/>
           </a:xfrm>
           <a:prstGeom prst="roundRect">
             <a:avLst/>
@@ -7558,13 +8504,13 @@
           <a:p>
             <a:pPr algn="ctr"/>
             <a:r>
-              <a:rPr sz="1900" b="1" i="0">
+              <a:rPr sz="1800" b="1" i="0">
                 <a:solidFill>
                   <a:srgbClr val="1E1E1E"/>
                 </a:solidFill>
                 <a:latin typeface="Times New Roman"/>
               </a:rPr>
-              <a:t>Current novelty status: candidate hypothesis, not demonstrated contribution</a:t>
+              <a:t>Conclusion: global appearance matching did not produce a large diagnostic gain</a:t>
             </a:r>
           </a:p>
         </p:txBody>
@@ -7878,7 +8824,7 @@
                 </a:solidFill>
                 <a:latin typeface="Times New Roman"/>
               </a:rPr>
-              <a:t>Classifier benefit of fitted degradation</a:t>
+              <a:t>A mechanism that beats B1 repeatedly</a:t>
             </a:r>
           </a:p>
           <a:p>
@@ -7910,7 +8856,7 @@
                 </a:solidFill>
                 <a:latin typeface="Times New Roman"/>
               </a:rPr>
-              <a:t>Fair longer-budget routing revisit</a:t>
+              <a:t>Fair latent-transition or routing study</a:t>
             </a:r>
           </a:p>
         </p:txBody>
@@ -8035,7 +8981,7 @@
                 </a:solidFill>
                 <a:latin typeface="Times New Roman"/>
               </a:rPr>
-              <a:t>Run only after Step 4 supports the premise</a:t>
+              <a:t>Freeze a bounded content-aware test before training</a:t>
             </a:r>
           </a:p>
         </p:txBody>

</xml_diff>

<commit_message>
Freeze evidence-led Step 5 mechanism direction
</commit_message>
<xml_diff>
--- a/research/codex/reports/BRSET_mBRSET_Research_Update.pptx
+++ b/research/codex/reports/BRSET_mBRSET_Research_Update.pptx
@@ -3161,7 +3161,7 @@
                 </a:solidFill>
                 <a:latin typeface="Times New Roman"/>
               </a:rPr>
-              <a:t>Evidence update: Step 4 seed-0 screen complete</a:t>
+              <a:t>Evidence update: Step 5 mechanism direction selected</a:t>
             </a:r>
           </a:p>
         </p:txBody>
@@ -8563,7 +8563,7 @@
                 </a:solidFill>
                 <a:latin typeface="Times New Roman"/>
               </a:rPr>
-              <a:t>Dong requests and world-model decision</a:t>
+              <a:t>Step 5: evidence-led mechanism decision</a:t>
             </a:r>
           </a:p>
         </p:txBody>
@@ -8699,7 +8699,7 @@
                 </a:solidFill>
                 <a:latin typeface="Times New Roman"/>
               </a:rPr>
-              <a:t>Matched baseline protocol</a:t>
+              <a:t>Joint B1 baseline across three seeds</a:t>
             </a:r>
           </a:p>
           <a:p>
@@ -8715,7 +8715,7 @@
                 </a:solidFill>
                 <a:latin typeface="Times New Roman"/>
               </a:rPr>
-              <a:t>DR/ME prevalence and sampling controls</a:t>
+              <a:t>Balance/exposure controls</a:t>
             </a:r>
           </a:p>
           <a:p>
@@ -8731,7 +8731,7 @@
                 </a:solidFill>
                 <a:latin typeface="Times New Roman"/>
               </a:rPr>
-              <a:t>Source-verified degradation examples</a:t>
+              <a:t>Negative appearance-augmentation screen</a:t>
             </a:r>
           </a:p>
         </p:txBody>
@@ -8785,7 +8785,7 @@
                 </a:solidFill>
                 <a:latin typeface="Times New Roman"/>
               </a:rPr>
-              <a:t>Open</a:t>
+              <a:t>Prerequisites</a:t>
             </a:r>
           </a:p>
         </p:txBody>
@@ -8824,7 +8824,7 @@
                 </a:solidFill>
                 <a:latin typeface="Times New Roman"/>
               </a:rPr>
-              <a:t>A mechanism that beats B1 repeatedly</a:t>
+              <a:t>Strict BRSET-only transfer baseline</a:t>
             </a:r>
           </a:p>
           <a:p>
@@ -8840,7 +8840,7 @@
                 </a:solidFill>
                 <a:latin typeface="Times New Roman"/>
               </a:rPr>
-              <a:t>Diagnostic-preservation evidence</a:t>
+              <a:t>CVPR 2026 GFP frozen-feature comparator</a:t>
             </a:r>
           </a:p>
           <a:p>
@@ -8856,7 +8856,7 @@
                 </a:solidFill>
                 <a:latin typeface="Times New Roman"/>
               </a:rPr>
-              <a:t>Fair latent-transition or routing study</a:t>
+              <a:t>Freeze action, losses, resume and no-test gates</a:t>
             </a:r>
           </a:p>
         </p:txBody>
@@ -8910,7 +8910,7 @@
                 </a:solidFill>
                 <a:latin typeface="Times New Roman"/>
               </a:rPr>
-              <a:t>World-model gate</a:t>
+              <a:t>Proposed test</a:t>
             </a:r>
           </a:p>
         </p:txBody>
@@ -8949,7 +8949,7 @@
                 </a:solidFill>
                 <a:latin typeface="Times New Roman"/>
               </a:rPr>
-              <a:t>CheXWorld, CVPR 2025: closest conceptual match</a:t>
+              <a:t>W1: blind paired consistency</a:t>
             </a:r>
           </a:p>
           <a:p>
@@ -8965,7 +8965,7 @@
                 </a:solidFill>
                 <a:latin typeface="Times New Roman"/>
               </a:rPr>
-              <a:t>GenDeg, CVPR 2025: separate diffusion option</a:t>
+              <a:t>W2: action-conditioned latent transition</a:t>
             </a:r>
           </a:p>
           <a:p>
@@ -8981,7 +8981,7 @@
                 </a:solidFill>
                 <a:latin typeface="Times New Roman"/>
               </a:rPr>
-              <a:t>Freeze a bounded content-aware test before training</a:t>
+              <a:t>W3: W2 plus DR/ME preservation</a:t>
             </a:r>
           </a:p>
         </p:txBody>

</xml_diff>

<commit_message>
Launch strict source-only Step 5 baseline
</commit_message>
<xml_diff>
--- a/research/codex/reports/BRSET_mBRSET_Research_Update.pptx
+++ b/research/codex/reports/BRSET_mBRSET_Research_Update.pptx
@@ -3161,7 +3161,7 @@
                 </a:solidFill>
                 <a:latin typeface="Times New Roman"/>
               </a:rPr>
-              <a:t>Evidence update: Step 5 mechanism direction selected</a:t>
+              <a:t>Evidence update: Step 5 strict source-only baseline running; spatial diagnostics next</a:t>
             </a:r>
           </a:p>
         </p:txBody>
@@ -8785,7 +8785,7 @@
                 </a:solidFill>
                 <a:latin typeface="Times New Roman"/>
               </a:rPr>
-              <a:t>Prerequisites</a:t>
+              <a:t>Evidence gate</a:t>
             </a:r>
           </a:p>
         </p:txBody>
@@ -8824,7 +8824,7 @@
                 </a:solidFill>
                 <a:latin typeface="Times New Roman"/>
               </a:rPr>
-              <a:t>Strict BRSET-only transfer baseline</a:t>
+              <a:t>Appearance-error intervals cross zero</a:t>
             </a:r>
           </a:p>
           <a:p>
@@ -8840,7 +8840,7 @@
                 </a:solidFill>
                 <a:latin typeface="Times New Roman"/>
               </a:rPr>
-              <a:t>CVPR 2026 GFP frozen-feature comparator</a:t>
+              <a:t>Positive-FN AUC: DR .555; ME .406</a:t>
             </a:r>
           </a:p>
           <a:p>
@@ -8856,7 +8856,7 @@
                 </a:solidFill>
                 <a:latin typeface="Times New Roman"/>
               </a:rPr>
-              <a:t>Freeze action, losses, resume and no-test gates</a:t>
+              <a:t>Suspend degradation-conditioned training</a:t>
             </a:r>
           </a:p>
         </p:txBody>
@@ -8910,7 +8910,7 @@
                 </a:solidFill>
                 <a:latin typeface="Times New Roman"/>
               </a:rPr>
-              <a:t>Proposed test</a:t>
+              <a:t>Next evidence</a:t>
             </a:r>
           </a:p>
         </p:txBody>
@@ -8949,7 +8949,7 @@
                 </a:solidFill>
                 <a:latin typeface="Times New Roman"/>
               </a:rPr>
-              <a:t>W1: blind paired consistency</a:t>
+              <a:t>Strict BRSET-only seed 0 running</a:t>
             </a:r>
           </a:p>
           <a:p>
@@ -8965,7 +8965,7 @@
                 </a:solidFill>
                 <a:latin typeface="Times New Roman"/>
               </a:rPr>
-              <a:t>W2: action-conditioned latent transition</a:t>
+              <a:t>GFP pooled-feature comparator</a:t>
             </a:r>
           </a:p>
           <a:p>
@@ -8981,7 +8981,7 @@
                 </a:solidFill>
                 <a:latin typeface="Times New Roman"/>
               </a:rPr>
-              <a:t>W3: W2 plus DR/ME preservation</a:t>
+              <a:t>Global vs label-specific spatial features</a:t>
             </a:r>
           </a:p>
         </p:txBody>

</xml_diff>

<commit_message>
Record verified source-only seed 0 result
</commit_message>
<xml_diff>
--- a/research/codex/reports/BRSET_mBRSET_Research_Update.pptx
+++ b/research/codex/reports/BRSET_mBRSET_Research_Update.pptx
@@ -3161,7 +3161,7 @@
                 </a:solidFill>
                 <a:latin typeface="Times New Roman"/>
               </a:rPr>
-              <a:t>Evidence update: Step 5 strict source-only baseline running; spatial diagnostics next</a:t>
+              <a:t>Evidence update: Step 5 source-only baseline complete; spatial diagnostics next</a:t>
             </a:r>
           </a:p>
         </p:txBody>
@@ -8949,7 +8949,7 @@
                 </a:solidFill>
                 <a:latin typeface="Times New Roman"/>
               </a:rPr>
-              <a:t>Strict BRSET-only seed 0 running</a:t>
+              <a:t>Source-only complete: DR/ME F1 0.722/0.697</a:t>
             </a:r>
           </a:p>
           <a:p>

</xml_diff>